<commit_message>
Included visualizations for base model comparisons
</commit_message>
<xml_diff>
--- a/Final_Presentation.pptx
+++ b/Final_Presentation.pptx
@@ -22,8 +22,8 @@
     <p:sldId id="1989" r:id="rId10"/>
     <p:sldId id="1990" r:id="rId11"/>
     <p:sldId id="1991" r:id="rId12"/>
-    <p:sldId id="1994" r:id="rId13"/>
-    <p:sldId id="1995" r:id="rId14"/>
+    <p:sldId id="1995" r:id="rId13"/>
+    <p:sldId id="1996" r:id="rId14"/>
     <p:sldId id="1992" r:id="rId15"/>
     <p:sldId id="1993" r:id="rId16"/>
     <p:sldId id="1982" r:id="rId17"/>
@@ -19586,7 +19586,7 @@
           <p:nvPr>
             <p:extLst>
               <p:ext uri="{D42A27DB-BD31-4B8C-83A1-F6EECF244321}">
-                <p14:modId xmlns:p14="http://schemas.microsoft.com/office/powerpoint/2010/main" val="3087534923"/>
+                <p14:modId xmlns:p14="http://schemas.microsoft.com/office/powerpoint/2010/main" val="1703136704"/>
               </p:ext>
             </p:extLst>
           </p:nvPr>
@@ -19752,7 +19752,7 @@
                         <a:rPr lang="en-US" sz="1800" dirty="0">
                           <a:hlinkClick r:id="rId4"/>
                         </a:rPr>
-                        <a:t>shuang@jh.edu</a:t>
+                        <a:t>shuan153@jh.edu</a:t>
                       </a:r>
                       <a:endParaRPr lang="en-US" sz="1800" dirty="0"/>
                     </a:p>
@@ -20008,6 +20008,2074 @@
           </a:p>
         </p:txBody>
       </p:sp>
+      <p:graphicFrame>
+        <p:nvGraphicFramePr>
+          <p:cNvPr id="5" name="Table 4">
+            <a:extLst>
+              <a:ext uri="{FF2B5EF4-FFF2-40B4-BE49-F238E27FC236}">
+                <a16:creationId xmlns:a16="http://schemas.microsoft.com/office/drawing/2014/main" id="{EAC4BEEC-D22F-3ACF-F556-84A771EBAE9B}"/>
+              </a:ext>
+            </a:extLst>
+          </p:cNvPr>
+          <p:cNvGraphicFramePr>
+            <a:graphicFrameLocks noGrp="1"/>
+          </p:cNvGraphicFramePr>
+          <p:nvPr>
+            <p:extLst>
+              <p:ext uri="{D42A27DB-BD31-4B8C-83A1-F6EECF244321}">
+                <p14:modId xmlns:p14="http://schemas.microsoft.com/office/powerpoint/2010/main" val="787129962"/>
+              </p:ext>
+            </p:extLst>
+          </p:nvPr>
+        </p:nvGraphicFramePr>
+        <p:xfrm>
+          <a:off x="1954281" y="3257341"/>
+          <a:ext cx="8283438" cy="2505075"/>
+        </p:xfrm>
+        <a:graphic>
+          <a:graphicData uri="http://schemas.openxmlformats.org/drawingml/2006/table">
+            <a:tbl>
+              <a:tblPr/>
+              <a:tblGrid>
+                <a:gridCol w="1007994">
+                  <a:extLst>
+                    <a:ext uri="{9D8B030D-6E8A-4147-A177-3AD203B41FA5}">
+                      <a16:colId xmlns:a16="http://schemas.microsoft.com/office/drawing/2014/main" val="3229122390"/>
+                    </a:ext>
+                  </a:extLst>
+                </a:gridCol>
+                <a:gridCol w="596348">
+                  <a:extLst>
+                    <a:ext uri="{9D8B030D-6E8A-4147-A177-3AD203B41FA5}">
+                      <a16:colId xmlns:a16="http://schemas.microsoft.com/office/drawing/2014/main" val="3348301737"/>
+                    </a:ext>
+                  </a:extLst>
+                </a:gridCol>
+                <a:gridCol w="2146852">
+                  <a:extLst>
+                    <a:ext uri="{9D8B030D-6E8A-4147-A177-3AD203B41FA5}">
+                      <a16:colId xmlns:a16="http://schemas.microsoft.com/office/drawing/2014/main" val="1734176775"/>
+                    </a:ext>
+                  </a:extLst>
+                </a:gridCol>
+                <a:gridCol w="1023731">
+                  <a:extLst>
+                    <a:ext uri="{9D8B030D-6E8A-4147-A177-3AD203B41FA5}">
+                      <a16:colId xmlns:a16="http://schemas.microsoft.com/office/drawing/2014/main" val="2235740553"/>
+                    </a:ext>
+                  </a:extLst>
+                </a:gridCol>
+                <a:gridCol w="3508513">
+                  <a:extLst>
+                    <a:ext uri="{9D8B030D-6E8A-4147-A177-3AD203B41FA5}">
+                      <a16:colId xmlns:a16="http://schemas.microsoft.com/office/drawing/2014/main" val="3939053188"/>
+                    </a:ext>
+                  </a:extLst>
+                </a:gridCol>
+              </a:tblGrid>
+              <a:tr h="209550">
+                <a:tc>
+                  <a:txBody>
+                    <a:bodyPr/>
+                    <a:lstStyle/>
+                    <a:p>
+                      <a:pPr algn="ctr" fontAlgn="ctr">
+                        <a:buNone/>
+                      </a:pPr>
+                      <a:r>
+                        <a:rPr lang="en-US" sz="1600" b="1" i="0" u="none" strike="noStrike" dirty="0">
+                          <a:solidFill>
+                            <a:srgbClr val="000000"/>
+                          </a:solidFill>
+                          <a:effectLst/>
+                          <a:latin typeface="Aptos Narrow" panose="020B0004020202020204" pitchFamily="34" charset="0"/>
+                        </a:rPr>
+                        <a:t>Model</a:t>
+                      </a:r>
+                    </a:p>
+                  </a:txBody>
+                  <a:tcPr marL="9525" marR="9525" marT="9525" marB="0" anchor="ctr">
+                    <a:lnL w="12700" cap="flat" cmpd="sng" algn="ctr">
+                      <a:solidFill>
+                        <a:srgbClr val="000000"/>
+                      </a:solidFill>
+                      <a:prstDash val="solid"/>
+                      <a:round/>
+                      <a:headEnd type="none" w="med" len="med"/>
+                      <a:tailEnd type="none" w="med" len="med"/>
+                    </a:lnL>
+                    <a:lnR w="6350" cap="flat" cmpd="sng" algn="ctr">
+                      <a:solidFill>
+                        <a:srgbClr val="000000"/>
+                      </a:solidFill>
+                      <a:prstDash val="solid"/>
+                      <a:round/>
+                      <a:headEnd type="none" w="med" len="med"/>
+                      <a:tailEnd type="none" w="med" len="med"/>
+                    </a:lnR>
+                    <a:lnT w="12700" cap="flat" cmpd="sng" algn="ctr">
+                      <a:solidFill>
+                        <a:srgbClr val="000000"/>
+                      </a:solidFill>
+                      <a:prstDash val="solid"/>
+                      <a:round/>
+                      <a:headEnd type="none" w="med" len="med"/>
+                      <a:tailEnd type="none" w="med" len="med"/>
+                    </a:lnT>
+                    <a:lnB w="12700" cap="flat" cmpd="sng" algn="ctr">
+                      <a:solidFill>
+                        <a:srgbClr val="000000"/>
+                      </a:solidFill>
+                      <a:prstDash val="solid"/>
+                      <a:round/>
+                      <a:headEnd type="none" w="med" len="med"/>
+                      <a:tailEnd type="none" w="med" len="med"/>
+                    </a:lnB>
+                    <a:noFill/>
+                  </a:tcPr>
+                </a:tc>
+                <a:tc>
+                  <a:txBody>
+                    <a:bodyPr/>
+                    <a:lstStyle/>
+                    <a:p>
+                      <a:pPr algn="ctr" fontAlgn="ctr">
+                        <a:buNone/>
+                      </a:pPr>
+                      <a:r>
+                        <a:rPr lang="en-US" sz="1600" b="1" i="0" u="none" strike="noStrike">
+                          <a:solidFill>
+                            <a:srgbClr val="000000"/>
+                          </a:solidFill>
+                          <a:effectLst/>
+                          <a:latin typeface="Aptos Narrow" panose="020B0004020202020204" pitchFamily="34" charset="0"/>
+                        </a:rPr>
+                        <a:t>Size</a:t>
+                      </a:r>
+                    </a:p>
+                  </a:txBody>
+                  <a:tcPr marL="9525" marR="9525" marT="9525" marB="0" anchor="ctr">
+                    <a:lnL w="6350" cap="flat" cmpd="sng" algn="ctr">
+                      <a:solidFill>
+                        <a:srgbClr val="000000"/>
+                      </a:solidFill>
+                      <a:prstDash val="solid"/>
+                      <a:round/>
+                      <a:headEnd type="none" w="med" len="med"/>
+                      <a:tailEnd type="none" w="med" len="med"/>
+                    </a:lnL>
+                    <a:lnR w="6350" cap="flat" cmpd="sng" algn="ctr">
+                      <a:solidFill>
+                        <a:srgbClr val="000000"/>
+                      </a:solidFill>
+                      <a:prstDash val="solid"/>
+                      <a:round/>
+                      <a:headEnd type="none" w="med" len="med"/>
+                      <a:tailEnd type="none" w="med" len="med"/>
+                    </a:lnR>
+                    <a:lnT w="12700" cap="flat" cmpd="sng" algn="ctr">
+                      <a:solidFill>
+                        <a:srgbClr val="000000"/>
+                      </a:solidFill>
+                      <a:prstDash val="solid"/>
+                      <a:round/>
+                      <a:headEnd type="none" w="med" len="med"/>
+                      <a:tailEnd type="none" w="med" len="med"/>
+                    </a:lnT>
+                    <a:lnB w="12700" cap="flat" cmpd="sng" algn="ctr">
+                      <a:solidFill>
+                        <a:srgbClr val="000000"/>
+                      </a:solidFill>
+                      <a:prstDash val="solid"/>
+                      <a:round/>
+                      <a:headEnd type="none" w="med" len="med"/>
+                      <a:tailEnd type="none" w="med" len="med"/>
+                    </a:lnB>
+                    <a:noFill/>
+                  </a:tcPr>
+                </a:tc>
+                <a:tc>
+                  <a:txBody>
+                    <a:bodyPr/>
+                    <a:lstStyle/>
+                    <a:p>
+                      <a:pPr algn="ctr" fontAlgn="ctr">
+                        <a:buNone/>
+                      </a:pPr>
+                      <a:r>
+                        <a:rPr lang="en-US" sz="1600" b="1" i="0" u="none" strike="noStrike" dirty="0">
+                          <a:solidFill>
+                            <a:srgbClr val="000000"/>
+                          </a:solidFill>
+                          <a:effectLst/>
+                          <a:latin typeface="Aptos Narrow" panose="020B0004020202020204" pitchFamily="34" charset="0"/>
+                        </a:rPr>
+                        <a:t>Avg Response Time (s)</a:t>
+                      </a:r>
+                    </a:p>
+                  </a:txBody>
+                  <a:tcPr marL="9525" marR="9525" marT="9525" marB="0" anchor="ctr">
+                    <a:lnL w="6350" cap="flat" cmpd="sng" algn="ctr">
+                      <a:solidFill>
+                        <a:srgbClr val="000000"/>
+                      </a:solidFill>
+                      <a:prstDash val="solid"/>
+                      <a:round/>
+                      <a:headEnd type="none" w="med" len="med"/>
+                      <a:tailEnd type="none" w="med" len="med"/>
+                    </a:lnL>
+                    <a:lnR w="6350" cap="flat" cmpd="sng" algn="ctr">
+                      <a:solidFill>
+                        <a:srgbClr val="000000"/>
+                      </a:solidFill>
+                      <a:prstDash val="solid"/>
+                      <a:round/>
+                      <a:headEnd type="none" w="med" len="med"/>
+                      <a:tailEnd type="none" w="med" len="med"/>
+                    </a:lnR>
+                    <a:lnT w="12700" cap="flat" cmpd="sng" algn="ctr">
+                      <a:solidFill>
+                        <a:srgbClr val="000000"/>
+                      </a:solidFill>
+                      <a:prstDash val="solid"/>
+                      <a:round/>
+                      <a:headEnd type="none" w="med" len="med"/>
+                      <a:tailEnd type="none" w="med" len="med"/>
+                    </a:lnT>
+                    <a:lnB w="12700" cap="flat" cmpd="sng" algn="ctr">
+                      <a:solidFill>
+                        <a:srgbClr val="000000"/>
+                      </a:solidFill>
+                      <a:prstDash val="solid"/>
+                      <a:round/>
+                      <a:headEnd type="none" w="med" len="med"/>
+                      <a:tailEnd type="none" w="med" len="med"/>
+                    </a:lnB>
+                    <a:noFill/>
+                  </a:tcPr>
+                </a:tc>
+                <a:tc>
+                  <a:txBody>
+                    <a:bodyPr/>
+                    <a:lstStyle/>
+                    <a:p>
+                      <a:pPr algn="ctr" fontAlgn="ctr">
+                        <a:buNone/>
+                      </a:pPr>
+                      <a:r>
+                        <a:rPr lang="en-US" sz="1600" b="1" i="0" u="none" strike="noStrike" dirty="0">
+                          <a:solidFill>
+                            <a:srgbClr val="000000"/>
+                          </a:solidFill>
+                          <a:effectLst/>
+                          <a:latin typeface="Aptos Narrow" panose="020B0004020202020204" pitchFamily="34" charset="0"/>
+                        </a:rPr>
+                        <a:t>Std Dev (s)</a:t>
+                      </a:r>
+                    </a:p>
+                  </a:txBody>
+                  <a:tcPr marL="9525" marR="9525" marT="9525" marB="0" anchor="ctr">
+                    <a:lnL w="6350" cap="flat" cmpd="sng" algn="ctr">
+                      <a:solidFill>
+                        <a:srgbClr val="000000"/>
+                      </a:solidFill>
+                      <a:prstDash val="solid"/>
+                      <a:round/>
+                      <a:headEnd type="none" w="med" len="med"/>
+                      <a:tailEnd type="none" w="med" len="med"/>
+                    </a:lnL>
+                    <a:lnR w="6350" cap="flat" cmpd="sng" algn="ctr">
+                      <a:solidFill>
+                        <a:srgbClr val="000000"/>
+                      </a:solidFill>
+                      <a:prstDash val="solid"/>
+                      <a:round/>
+                      <a:headEnd type="none" w="med" len="med"/>
+                      <a:tailEnd type="none" w="med" len="med"/>
+                    </a:lnR>
+                    <a:lnT w="12700" cap="flat" cmpd="sng" algn="ctr">
+                      <a:solidFill>
+                        <a:srgbClr val="000000"/>
+                      </a:solidFill>
+                      <a:prstDash val="solid"/>
+                      <a:round/>
+                      <a:headEnd type="none" w="med" len="med"/>
+                      <a:tailEnd type="none" w="med" len="med"/>
+                    </a:lnT>
+                    <a:lnB w="12700" cap="flat" cmpd="sng" algn="ctr">
+                      <a:solidFill>
+                        <a:srgbClr val="000000"/>
+                      </a:solidFill>
+                      <a:prstDash val="solid"/>
+                      <a:round/>
+                      <a:headEnd type="none" w="med" len="med"/>
+                      <a:tailEnd type="none" w="med" len="med"/>
+                    </a:lnB>
+                    <a:noFill/>
+                  </a:tcPr>
+                </a:tc>
+                <a:tc>
+                  <a:txBody>
+                    <a:bodyPr/>
+                    <a:lstStyle/>
+                    <a:p>
+                      <a:pPr algn="ctr" fontAlgn="ctr">
+                        <a:buNone/>
+                      </a:pPr>
+                      <a:r>
+                        <a:rPr lang="en-US" sz="1600" b="1" i="0" u="none" strike="noStrike">
+                          <a:solidFill>
+                            <a:srgbClr val="000000"/>
+                          </a:solidFill>
+                          <a:effectLst/>
+                          <a:latin typeface="Aptos Narrow" panose="020B0004020202020204" pitchFamily="34" charset="0"/>
+                        </a:rPr>
+                        <a:t>Key Notes</a:t>
+                      </a:r>
+                    </a:p>
+                  </a:txBody>
+                  <a:tcPr marL="9525" marR="9525" marT="9525" marB="0" anchor="ctr">
+                    <a:lnL w="6350" cap="flat" cmpd="sng" algn="ctr">
+                      <a:solidFill>
+                        <a:srgbClr val="000000"/>
+                      </a:solidFill>
+                      <a:prstDash val="solid"/>
+                      <a:round/>
+                      <a:headEnd type="none" w="med" len="med"/>
+                      <a:tailEnd type="none" w="med" len="med"/>
+                    </a:lnL>
+                    <a:lnR w="12700" cap="flat" cmpd="sng" algn="ctr">
+                      <a:solidFill>
+                        <a:srgbClr val="000000"/>
+                      </a:solidFill>
+                      <a:prstDash val="solid"/>
+                      <a:round/>
+                      <a:headEnd type="none" w="med" len="med"/>
+                      <a:tailEnd type="none" w="med" len="med"/>
+                    </a:lnR>
+                    <a:lnT w="12700" cap="flat" cmpd="sng" algn="ctr">
+                      <a:solidFill>
+                        <a:srgbClr val="000000"/>
+                      </a:solidFill>
+                      <a:prstDash val="solid"/>
+                      <a:round/>
+                      <a:headEnd type="none" w="med" len="med"/>
+                      <a:tailEnd type="none" w="med" len="med"/>
+                    </a:lnT>
+                    <a:lnB w="12700" cap="flat" cmpd="sng" algn="ctr">
+                      <a:solidFill>
+                        <a:srgbClr val="000000"/>
+                      </a:solidFill>
+                      <a:prstDash val="solid"/>
+                      <a:round/>
+                      <a:headEnd type="none" w="med" len="med"/>
+                      <a:tailEnd type="none" w="med" len="med"/>
+                    </a:lnB>
+                    <a:noFill/>
+                  </a:tcPr>
+                </a:tc>
+                <a:extLst>
+                  <a:ext uri="{0D108BD9-81ED-4DB2-BD59-A6C34878D82A}">
+                    <a16:rowId xmlns:a16="http://schemas.microsoft.com/office/drawing/2014/main" val="3499689647"/>
+                  </a:ext>
+                </a:extLst>
+              </a:tr>
+              <a:tr h="200025">
+                <a:tc rowSpan="2">
+                  <a:txBody>
+                    <a:bodyPr/>
+                    <a:lstStyle/>
+                    <a:p>
+                      <a:pPr algn="ctr" fontAlgn="ctr">
+                        <a:buNone/>
+                      </a:pPr>
+                      <a:r>
+                        <a:rPr lang="en-US" sz="1600" b="1" i="0" u="none" strike="noStrike">
+                          <a:solidFill>
+                            <a:srgbClr val="000000"/>
+                          </a:solidFill>
+                          <a:effectLst/>
+                          <a:latin typeface="Aptos Narrow" panose="020B0004020202020204" pitchFamily="34" charset="0"/>
+                        </a:rPr>
+                        <a:t>GPT-OSS</a:t>
+                      </a:r>
+                    </a:p>
+                  </a:txBody>
+                  <a:tcPr marL="9525" marR="9525" marT="9525" marB="0" anchor="ctr">
+                    <a:lnL w="12700" cap="flat" cmpd="sng" algn="ctr">
+                      <a:solidFill>
+                        <a:srgbClr val="000000"/>
+                      </a:solidFill>
+                      <a:prstDash val="solid"/>
+                      <a:round/>
+                      <a:headEnd type="none" w="med" len="med"/>
+                      <a:tailEnd type="none" w="med" len="med"/>
+                    </a:lnL>
+                    <a:lnR w="6350" cap="flat" cmpd="sng" algn="ctr">
+                      <a:solidFill>
+                        <a:srgbClr val="000000"/>
+                      </a:solidFill>
+                      <a:prstDash val="solid"/>
+                      <a:round/>
+                      <a:headEnd type="none" w="med" len="med"/>
+                      <a:tailEnd type="none" w="med" len="med"/>
+                    </a:lnR>
+                    <a:lnT w="12700" cap="flat" cmpd="sng" algn="ctr">
+                      <a:solidFill>
+                        <a:srgbClr val="000000"/>
+                      </a:solidFill>
+                      <a:prstDash val="solid"/>
+                      <a:round/>
+                      <a:headEnd type="none" w="med" len="med"/>
+                      <a:tailEnd type="none" w="med" len="med"/>
+                    </a:lnT>
+                    <a:lnB w="12700" cap="flat" cmpd="sng" algn="ctr">
+                      <a:solidFill>
+                        <a:srgbClr val="000000"/>
+                      </a:solidFill>
+                      <a:prstDash val="solid"/>
+                      <a:round/>
+                      <a:headEnd type="none" w="med" len="med"/>
+                      <a:tailEnd type="none" w="med" len="med"/>
+                    </a:lnB>
+                    <a:noFill/>
+                  </a:tcPr>
+                </a:tc>
+                <a:tc>
+                  <a:txBody>
+                    <a:bodyPr/>
+                    <a:lstStyle/>
+                    <a:p>
+                      <a:pPr algn="ctr" fontAlgn="ctr">
+                        <a:buNone/>
+                      </a:pPr>
+                      <a:r>
+                        <a:rPr lang="en-US" sz="1600" b="0" i="0" u="none" strike="noStrike" dirty="0">
+                          <a:solidFill>
+                            <a:srgbClr val="000000"/>
+                          </a:solidFill>
+                          <a:effectLst/>
+                          <a:latin typeface="Aptos Narrow" panose="020B0004020202020204" pitchFamily="34" charset="0"/>
+                        </a:rPr>
+                        <a:t>20B</a:t>
+                      </a:r>
+                    </a:p>
+                  </a:txBody>
+                  <a:tcPr marL="9525" marR="9525" marT="9525" marB="0" anchor="ctr">
+                    <a:lnL w="6350" cap="flat" cmpd="sng" algn="ctr">
+                      <a:solidFill>
+                        <a:srgbClr val="000000"/>
+                      </a:solidFill>
+                      <a:prstDash val="solid"/>
+                      <a:round/>
+                      <a:headEnd type="none" w="med" len="med"/>
+                      <a:tailEnd type="none" w="med" len="med"/>
+                    </a:lnL>
+                    <a:lnR w="6350" cap="flat" cmpd="sng" algn="ctr">
+                      <a:solidFill>
+                        <a:srgbClr val="000000"/>
+                      </a:solidFill>
+                      <a:prstDash val="solid"/>
+                      <a:round/>
+                      <a:headEnd type="none" w="med" len="med"/>
+                      <a:tailEnd type="none" w="med" len="med"/>
+                    </a:lnR>
+                    <a:lnT w="12700" cap="flat" cmpd="sng" algn="ctr">
+                      <a:solidFill>
+                        <a:srgbClr val="000000"/>
+                      </a:solidFill>
+                      <a:prstDash val="solid"/>
+                      <a:round/>
+                      <a:headEnd type="none" w="med" len="med"/>
+                      <a:tailEnd type="none" w="med" len="med"/>
+                    </a:lnT>
+                    <a:lnB w="6350" cap="flat" cmpd="sng" algn="ctr">
+                      <a:solidFill>
+                        <a:srgbClr val="000000"/>
+                      </a:solidFill>
+                      <a:prstDash val="solid"/>
+                      <a:round/>
+                      <a:headEnd type="none" w="med" len="med"/>
+                      <a:tailEnd type="none" w="med" len="med"/>
+                    </a:lnB>
+                    <a:noFill/>
+                  </a:tcPr>
+                </a:tc>
+                <a:tc>
+                  <a:txBody>
+                    <a:bodyPr/>
+                    <a:lstStyle/>
+                    <a:p>
+                      <a:pPr algn="ctr" fontAlgn="ctr">
+                        <a:buNone/>
+                      </a:pPr>
+                      <a:r>
+                        <a:rPr lang="en-US" sz="1600" b="0" i="0" u="none" strike="noStrike" dirty="0">
+                          <a:solidFill>
+                            <a:srgbClr val="000000"/>
+                          </a:solidFill>
+                          <a:effectLst/>
+                          <a:latin typeface="Aptos Narrow" panose="020B0004020202020204" pitchFamily="34" charset="0"/>
+                        </a:rPr>
+                        <a:t> </a:t>
+                      </a:r>
+                    </a:p>
+                  </a:txBody>
+                  <a:tcPr marL="9525" marR="9525" marT="9525" marB="0" anchor="ctr">
+                    <a:lnL w="6350" cap="flat" cmpd="sng" algn="ctr">
+                      <a:solidFill>
+                        <a:srgbClr val="000000"/>
+                      </a:solidFill>
+                      <a:prstDash val="solid"/>
+                      <a:round/>
+                      <a:headEnd type="none" w="med" len="med"/>
+                      <a:tailEnd type="none" w="med" len="med"/>
+                    </a:lnL>
+                    <a:lnR w="6350" cap="flat" cmpd="sng" algn="ctr">
+                      <a:solidFill>
+                        <a:srgbClr val="000000"/>
+                      </a:solidFill>
+                      <a:prstDash val="solid"/>
+                      <a:round/>
+                      <a:headEnd type="none" w="med" len="med"/>
+                      <a:tailEnd type="none" w="med" len="med"/>
+                    </a:lnR>
+                    <a:lnT w="12700" cap="flat" cmpd="sng" algn="ctr">
+                      <a:solidFill>
+                        <a:srgbClr val="000000"/>
+                      </a:solidFill>
+                      <a:prstDash val="solid"/>
+                      <a:round/>
+                      <a:headEnd type="none" w="med" len="med"/>
+                      <a:tailEnd type="none" w="med" len="med"/>
+                    </a:lnT>
+                    <a:lnB w="6350" cap="flat" cmpd="sng" algn="ctr">
+                      <a:solidFill>
+                        <a:srgbClr val="000000"/>
+                      </a:solidFill>
+                      <a:prstDash val="solid"/>
+                      <a:round/>
+                      <a:headEnd type="none" w="med" len="med"/>
+                      <a:tailEnd type="none" w="med" len="med"/>
+                    </a:lnB>
+                    <a:noFill/>
+                  </a:tcPr>
+                </a:tc>
+                <a:tc>
+                  <a:txBody>
+                    <a:bodyPr/>
+                    <a:lstStyle/>
+                    <a:p>
+                      <a:pPr algn="ctr" fontAlgn="ctr">
+                        <a:buNone/>
+                      </a:pPr>
+                      <a:r>
+                        <a:rPr lang="en-US" sz="1600" b="0" i="0" u="none" strike="noStrike">
+                          <a:solidFill>
+                            <a:srgbClr val="000000"/>
+                          </a:solidFill>
+                          <a:effectLst/>
+                          <a:latin typeface="Aptos Narrow" panose="020B0004020202020204" pitchFamily="34" charset="0"/>
+                        </a:rPr>
+                        <a:t> </a:t>
+                      </a:r>
+                    </a:p>
+                  </a:txBody>
+                  <a:tcPr marL="9525" marR="9525" marT="9525" marB="0" anchor="ctr">
+                    <a:lnL w="6350" cap="flat" cmpd="sng" algn="ctr">
+                      <a:solidFill>
+                        <a:srgbClr val="000000"/>
+                      </a:solidFill>
+                      <a:prstDash val="solid"/>
+                      <a:round/>
+                      <a:headEnd type="none" w="med" len="med"/>
+                      <a:tailEnd type="none" w="med" len="med"/>
+                    </a:lnL>
+                    <a:lnR w="6350" cap="flat" cmpd="sng" algn="ctr">
+                      <a:solidFill>
+                        <a:srgbClr val="000000"/>
+                      </a:solidFill>
+                      <a:prstDash val="solid"/>
+                      <a:round/>
+                      <a:headEnd type="none" w="med" len="med"/>
+                      <a:tailEnd type="none" w="med" len="med"/>
+                    </a:lnR>
+                    <a:lnT w="12700" cap="flat" cmpd="sng" algn="ctr">
+                      <a:solidFill>
+                        <a:srgbClr val="000000"/>
+                      </a:solidFill>
+                      <a:prstDash val="solid"/>
+                      <a:round/>
+                      <a:headEnd type="none" w="med" len="med"/>
+                      <a:tailEnd type="none" w="med" len="med"/>
+                    </a:lnT>
+                    <a:lnB w="6350" cap="flat" cmpd="sng" algn="ctr">
+                      <a:solidFill>
+                        <a:srgbClr val="000000"/>
+                      </a:solidFill>
+                      <a:prstDash val="solid"/>
+                      <a:round/>
+                      <a:headEnd type="none" w="med" len="med"/>
+                      <a:tailEnd type="none" w="med" len="med"/>
+                    </a:lnB>
+                    <a:noFill/>
+                  </a:tcPr>
+                </a:tc>
+                <a:tc>
+                  <a:txBody>
+                    <a:bodyPr/>
+                    <a:lstStyle/>
+                    <a:p>
+                      <a:pPr algn="l" fontAlgn="ctr">
+                        <a:buNone/>
+                      </a:pPr>
+                      <a:r>
+                        <a:rPr lang="en-US" sz="1600" b="0" i="0" u="none" strike="noStrike">
+                          <a:solidFill>
+                            <a:srgbClr val="000000"/>
+                          </a:solidFill>
+                          <a:effectLst/>
+                          <a:latin typeface="Aptos Narrow" panose="020B0004020202020204" pitchFamily="34" charset="0"/>
+                        </a:rPr>
+                        <a:t>Strong baseline model; good speed and quality</a:t>
+                      </a:r>
+                    </a:p>
+                  </a:txBody>
+                  <a:tcPr marL="9525" marR="9525" marT="9525" marB="0" anchor="ctr">
+                    <a:lnL w="6350" cap="flat" cmpd="sng" algn="ctr">
+                      <a:solidFill>
+                        <a:srgbClr val="000000"/>
+                      </a:solidFill>
+                      <a:prstDash val="solid"/>
+                      <a:round/>
+                      <a:headEnd type="none" w="med" len="med"/>
+                      <a:tailEnd type="none" w="med" len="med"/>
+                    </a:lnL>
+                    <a:lnR w="12700" cap="flat" cmpd="sng" algn="ctr">
+                      <a:solidFill>
+                        <a:srgbClr val="000000"/>
+                      </a:solidFill>
+                      <a:prstDash val="solid"/>
+                      <a:round/>
+                      <a:headEnd type="none" w="med" len="med"/>
+                      <a:tailEnd type="none" w="med" len="med"/>
+                    </a:lnR>
+                    <a:lnT w="12700" cap="flat" cmpd="sng" algn="ctr">
+                      <a:solidFill>
+                        <a:srgbClr val="000000"/>
+                      </a:solidFill>
+                      <a:prstDash val="solid"/>
+                      <a:round/>
+                      <a:headEnd type="none" w="med" len="med"/>
+                      <a:tailEnd type="none" w="med" len="med"/>
+                    </a:lnT>
+                    <a:lnB w="6350" cap="flat" cmpd="sng" algn="ctr">
+                      <a:solidFill>
+                        <a:srgbClr val="000000"/>
+                      </a:solidFill>
+                      <a:prstDash val="solid"/>
+                      <a:round/>
+                      <a:headEnd type="none" w="med" len="med"/>
+                      <a:tailEnd type="none" w="med" len="med"/>
+                    </a:lnB>
+                    <a:noFill/>
+                  </a:tcPr>
+                </a:tc>
+                <a:extLst>
+                  <a:ext uri="{0D108BD9-81ED-4DB2-BD59-A6C34878D82A}">
+                    <a16:rowId xmlns:a16="http://schemas.microsoft.com/office/drawing/2014/main" val="3916794688"/>
+                  </a:ext>
+                </a:extLst>
+              </a:tr>
+              <a:tr h="209550">
+                <a:tc vMerge="1">
+                  <a:txBody>
+                    <a:bodyPr/>
+                    <a:lstStyle/>
+                    <a:p>
+                      <a:endParaRPr lang="en-US"/>
+                    </a:p>
+                  </a:txBody>
+                  <a:tcPr/>
+                </a:tc>
+                <a:tc>
+                  <a:txBody>
+                    <a:bodyPr/>
+                    <a:lstStyle/>
+                    <a:p>
+                      <a:pPr algn="ctr" fontAlgn="ctr">
+                        <a:buNone/>
+                      </a:pPr>
+                      <a:r>
+                        <a:rPr lang="en-US" sz="1600" b="0" i="0" u="none" strike="noStrike">
+                          <a:solidFill>
+                            <a:srgbClr val="000000"/>
+                          </a:solidFill>
+                          <a:effectLst/>
+                          <a:latin typeface="Aptos Narrow" panose="020B0004020202020204" pitchFamily="34" charset="0"/>
+                        </a:rPr>
+                        <a:t>120B</a:t>
+                      </a:r>
+                    </a:p>
+                  </a:txBody>
+                  <a:tcPr marL="9525" marR="9525" marT="9525" marB="0" anchor="ctr">
+                    <a:lnL w="6350" cap="flat" cmpd="sng" algn="ctr">
+                      <a:solidFill>
+                        <a:srgbClr val="000000"/>
+                      </a:solidFill>
+                      <a:prstDash val="solid"/>
+                      <a:round/>
+                      <a:headEnd type="none" w="med" len="med"/>
+                      <a:tailEnd type="none" w="med" len="med"/>
+                    </a:lnL>
+                    <a:lnR w="6350" cap="flat" cmpd="sng" algn="ctr">
+                      <a:solidFill>
+                        <a:srgbClr val="000000"/>
+                      </a:solidFill>
+                      <a:prstDash val="solid"/>
+                      <a:round/>
+                      <a:headEnd type="none" w="med" len="med"/>
+                      <a:tailEnd type="none" w="med" len="med"/>
+                    </a:lnR>
+                    <a:lnT w="6350" cap="flat" cmpd="sng" algn="ctr">
+                      <a:solidFill>
+                        <a:srgbClr val="000000"/>
+                      </a:solidFill>
+                      <a:prstDash val="solid"/>
+                      <a:round/>
+                      <a:headEnd type="none" w="med" len="med"/>
+                      <a:tailEnd type="none" w="med" len="med"/>
+                    </a:lnT>
+                    <a:lnB w="12700" cap="flat" cmpd="sng" algn="ctr">
+                      <a:solidFill>
+                        <a:srgbClr val="000000"/>
+                      </a:solidFill>
+                      <a:prstDash val="solid"/>
+                      <a:round/>
+                      <a:headEnd type="none" w="med" len="med"/>
+                      <a:tailEnd type="none" w="med" len="med"/>
+                    </a:lnB>
+                    <a:noFill/>
+                  </a:tcPr>
+                </a:tc>
+                <a:tc>
+                  <a:txBody>
+                    <a:bodyPr/>
+                    <a:lstStyle/>
+                    <a:p>
+                      <a:pPr algn="ctr" fontAlgn="ctr">
+                        <a:buNone/>
+                      </a:pPr>
+                      <a:r>
+                        <a:rPr lang="en-US" sz="1600" b="0" i="0" u="none" strike="noStrike" dirty="0">
+                          <a:solidFill>
+                            <a:srgbClr val="000000"/>
+                          </a:solidFill>
+                          <a:effectLst/>
+                          <a:latin typeface="Aptos Narrow" panose="020B0004020202020204" pitchFamily="34" charset="0"/>
+                        </a:rPr>
+                        <a:t> </a:t>
+                      </a:r>
+                    </a:p>
+                  </a:txBody>
+                  <a:tcPr marL="9525" marR="9525" marT="9525" marB="0" anchor="ctr">
+                    <a:lnL w="6350" cap="flat" cmpd="sng" algn="ctr">
+                      <a:solidFill>
+                        <a:srgbClr val="000000"/>
+                      </a:solidFill>
+                      <a:prstDash val="solid"/>
+                      <a:round/>
+                      <a:headEnd type="none" w="med" len="med"/>
+                      <a:tailEnd type="none" w="med" len="med"/>
+                    </a:lnL>
+                    <a:lnR w="6350" cap="flat" cmpd="sng" algn="ctr">
+                      <a:solidFill>
+                        <a:srgbClr val="000000"/>
+                      </a:solidFill>
+                      <a:prstDash val="solid"/>
+                      <a:round/>
+                      <a:headEnd type="none" w="med" len="med"/>
+                      <a:tailEnd type="none" w="med" len="med"/>
+                    </a:lnR>
+                    <a:lnT w="6350" cap="flat" cmpd="sng" algn="ctr">
+                      <a:solidFill>
+                        <a:srgbClr val="000000"/>
+                      </a:solidFill>
+                      <a:prstDash val="solid"/>
+                      <a:round/>
+                      <a:headEnd type="none" w="med" len="med"/>
+                      <a:tailEnd type="none" w="med" len="med"/>
+                    </a:lnT>
+                    <a:lnB w="12700" cap="flat" cmpd="sng" algn="ctr">
+                      <a:solidFill>
+                        <a:srgbClr val="000000"/>
+                      </a:solidFill>
+                      <a:prstDash val="solid"/>
+                      <a:round/>
+                      <a:headEnd type="none" w="med" len="med"/>
+                      <a:tailEnd type="none" w="med" len="med"/>
+                    </a:lnB>
+                    <a:noFill/>
+                  </a:tcPr>
+                </a:tc>
+                <a:tc>
+                  <a:txBody>
+                    <a:bodyPr/>
+                    <a:lstStyle/>
+                    <a:p>
+                      <a:pPr algn="ctr" fontAlgn="ctr">
+                        <a:buNone/>
+                      </a:pPr>
+                      <a:r>
+                        <a:rPr lang="en-US" sz="1600" b="0" i="0" u="none" strike="noStrike" dirty="0">
+                          <a:solidFill>
+                            <a:srgbClr val="000000"/>
+                          </a:solidFill>
+                          <a:effectLst/>
+                          <a:latin typeface="Aptos Narrow" panose="020B0004020202020204" pitchFamily="34" charset="0"/>
+                        </a:rPr>
+                        <a:t> </a:t>
+                      </a:r>
+                    </a:p>
+                  </a:txBody>
+                  <a:tcPr marL="9525" marR="9525" marT="9525" marB="0" anchor="ctr">
+                    <a:lnL w="6350" cap="flat" cmpd="sng" algn="ctr">
+                      <a:solidFill>
+                        <a:srgbClr val="000000"/>
+                      </a:solidFill>
+                      <a:prstDash val="solid"/>
+                      <a:round/>
+                      <a:headEnd type="none" w="med" len="med"/>
+                      <a:tailEnd type="none" w="med" len="med"/>
+                    </a:lnL>
+                    <a:lnR w="6350" cap="flat" cmpd="sng" algn="ctr">
+                      <a:solidFill>
+                        <a:srgbClr val="000000"/>
+                      </a:solidFill>
+                      <a:prstDash val="solid"/>
+                      <a:round/>
+                      <a:headEnd type="none" w="med" len="med"/>
+                      <a:tailEnd type="none" w="med" len="med"/>
+                    </a:lnR>
+                    <a:lnT w="6350" cap="flat" cmpd="sng" algn="ctr">
+                      <a:solidFill>
+                        <a:srgbClr val="000000"/>
+                      </a:solidFill>
+                      <a:prstDash val="solid"/>
+                      <a:round/>
+                      <a:headEnd type="none" w="med" len="med"/>
+                      <a:tailEnd type="none" w="med" len="med"/>
+                    </a:lnT>
+                    <a:lnB w="12700" cap="flat" cmpd="sng" algn="ctr">
+                      <a:solidFill>
+                        <a:srgbClr val="000000"/>
+                      </a:solidFill>
+                      <a:prstDash val="solid"/>
+                      <a:round/>
+                      <a:headEnd type="none" w="med" len="med"/>
+                      <a:tailEnd type="none" w="med" len="med"/>
+                    </a:lnB>
+                    <a:noFill/>
+                  </a:tcPr>
+                </a:tc>
+                <a:tc>
+                  <a:txBody>
+                    <a:bodyPr/>
+                    <a:lstStyle/>
+                    <a:p>
+                      <a:pPr algn="l" fontAlgn="ctr">
+                        <a:buNone/>
+                      </a:pPr>
+                      <a:r>
+                        <a:rPr lang="en-US" sz="1600" b="0" i="0" u="none" strike="noStrike">
+                          <a:solidFill>
+                            <a:srgbClr val="000000"/>
+                          </a:solidFill>
+                          <a:effectLst/>
+                          <a:latin typeface="Aptos Narrow" panose="020B0004020202020204" pitchFamily="34" charset="0"/>
+                        </a:rPr>
+                        <a:t>Slowest; large-scale reasoning; heavy GPU load</a:t>
+                      </a:r>
+                    </a:p>
+                  </a:txBody>
+                  <a:tcPr marL="9525" marR="9525" marT="9525" marB="0" anchor="ctr">
+                    <a:lnL w="6350" cap="flat" cmpd="sng" algn="ctr">
+                      <a:solidFill>
+                        <a:srgbClr val="000000"/>
+                      </a:solidFill>
+                      <a:prstDash val="solid"/>
+                      <a:round/>
+                      <a:headEnd type="none" w="med" len="med"/>
+                      <a:tailEnd type="none" w="med" len="med"/>
+                    </a:lnL>
+                    <a:lnR w="12700" cap="flat" cmpd="sng" algn="ctr">
+                      <a:solidFill>
+                        <a:srgbClr val="000000"/>
+                      </a:solidFill>
+                      <a:prstDash val="solid"/>
+                      <a:round/>
+                      <a:headEnd type="none" w="med" len="med"/>
+                      <a:tailEnd type="none" w="med" len="med"/>
+                    </a:lnR>
+                    <a:lnT w="6350" cap="flat" cmpd="sng" algn="ctr">
+                      <a:solidFill>
+                        <a:srgbClr val="000000"/>
+                      </a:solidFill>
+                      <a:prstDash val="solid"/>
+                      <a:round/>
+                      <a:headEnd type="none" w="med" len="med"/>
+                      <a:tailEnd type="none" w="med" len="med"/>
+                    </a:lnT>
+                    <a:lnB w="12700" cap="flat" cmpd="sng" algn="ctr">
+                      <a:solidFill>
+                        <a:srgbClr val="000000"/>
+                      </a:solidFill>
+                      <a:prstDash val="solid"/>
+                      <a:round/>
+                      <a:headEnd type="none" w="med" len="med"/>
+                      <a:tailEnd type="none" w="med" len="med"/>
+                    </a:lnB>
+                    <a:noFill/>
+                  </a:tcPr>
+                </a:tc>
+                <a:extLst>
+                  <a:ext uri="{0D108BD9-81ED-4DB2-BD59-A6C34878D82A}">
+                    <a16:rowId xmlns:a16="http://schemas.microsoft.com/office/drawing/2014/main" val="3773285734"/>
+                  </a:ext>
+                </a:extLst>
+              </a:tr>
+              <a:tr h="200025">
+                <a:tc rowSpan="2">
+                  <a:txBody>
+                    <a:bodyPr/>
+                    <a:lstStyle/>
+                    <a:p>
+                      <a:pPr algn="ctr" fontAlgn="ctr">
+                        <a:buNone/>
+                      </a:pPr>
+                      <a:r>
+                        <a:rPr lang="en-US" sz="1600" b="1" i="0" u="none" strike="noStrike">
+                          <a:solidFill>
+                            <a:srgbClr val="000000"/>
+                          </a:solidFill>
+                          <a:effectLst/>
+                          <a:latin typeface="Aptos Narrow" panose="020B0004020202020204" pitchFamily="34" charset="0"/>
+                        </a:rPr>
+                        <a:t>Qwen 3</a:t>
+                      </a:r>
+                    </a:p>
+                  </a:txBody>
+                  <a:tcPr marL="9525" marR="9525" marT="9525" marB="0" anchor="ctr">
+                    <a:lnL w="12700" cap="flat" cmpd="sng" algn="ctr">
+                      <a:solidFill>
+                        <a:srgbClr val="000000"/>
+                      </a:solidFill>
+                      <a:prstDash val="solid"/>
+                      <a:round/>
+                      <a:headEnd type="none" w="med" len="med"/>
+                      <a:tailEnd type="none" w="med" len="med"/>
+                    </a:lnL>
+                    <a:lnR w="6350" cap="flat" cmpd="sng" algn="ctr">
+                      <a:solidFill>
+                        <a:srgbClr val="000000"/>
+                      </a:solidFill>
+                      <a:prstDash val="solid"/>
+                      <a:round/>
+                      <a:headEnd type="none" w="med" len="med"/>
+                      <a:tailEnd type="none" w="med" len="med"/>
+                    </a:lnR>
+                    <a:lnT w="12700" cap="flat" cmpd="sng" algn="ctr">
+                      <a:solidFill>
+                        <a:srgbClr val="000000"/>
+                      </a:solidFill>
+                      <a:prstDash val="solid"/>
+                      <a:round/>
+                      <a:headEnd type="none" w="med" len="med"/>
+                      <a:tailEnd type="none" w="med" len="med"/>
+                    </a:lnT>
+                    <a:lnB w="12700" cap="flat" cmpd="sng" algn="ctr">
+                      <a:solidFill>
+                        <a:srgbClr val="000000"/>
+                      </a:solidFill>
+                      <a:prstDash val="solid"/>
+                      <a:round/>
+                      <a:headEnd type="none" w="med" len="med"/>
+                      <a:tailEnd type="none" w="med" len="med"/>
+                    </a:lnB>
+                    <a:noFill/>
+                  </a:tcPr>
+                </a:tc>
+                <a:tc>
+                  <a:txBody>
+                    <a:bodyPr/>
+                    <a:lstStyle/>
+                    <a:p>
+                      <a:pPr algn="ctr" fontAlgn="ctr">
+                        <a:buNone/>
+                      </a:pPr>
+                      <a:r>
+                        <a:rPr lang="en-US" sz="1600" b="0" i="0" u="none" strike="noStrike">
+                          <a:solidFill>
+                            <a:srgbClr val="000000"/>
+                          </a:solidFill>
+                          <a:effectLst/>
+                          <a:latin typeface="Aptos Narrow" panose="020B0004020202020204" pitchFamily="34" charset="0"/>
+                        </a:rPr>
+                        <a:t>4B</a:t>
+                      </a:r>
+                    </a:p>
+                  </a:txBody>
+                  <a:tcPr marL="9525" marR="9525" marT="9525" marB="0" anchor="ctr">
+                    <a:lnL w="6350" cap="flat" cmpd="sng" algn="ctr">
+                      <a:solidFill>
+                        <a:srgbClr val="000000"/>
+                      </a:solidFill>
+                      <a:prstDash val="solid"/>
+                      <a:round/>
+                      <a:headEnd type="none" w="med" len="med"/>
+                      <a:tailEnd type="none" w="med" len="med"/>
+                    </a:lnL>
+                    <a:lnR w="6350" cap="flat" cmpd="sng" algn="ctr">
+                      <a:solidFill>
+                        <a:srgbClr val="000000"/>
+                      </a:solidFill>
+                      <a:prstDash val="solid"/>
+                      <a:round/>
+                      <a:headEnd type="none" w="med" len="med"/>
+                      <a:tailEnd type="none" w="med" len="med"/>
+                    </a:lnR>
+                    <a:lnT w="12700" cap="flat" cmpd="sng" algn="ctr">
+                      <a:solidFill>
+                        <a:srgbClr val="000000"/>
+                      </a:solidFill>
+                      <a:prstDash val="solid"/>
+                      <a:round/>
+                      <a:headEnd type="none" w="med" len="med"/>
+                      <a:tailEnd type="none" w="med" len="med"/>
+                    </a:lnT>
+                    <a:lnB w="6350" cap="flat" cmpd="sng" algn="ctr">
+                      <a:solidFill>
+                        <a:srgbClr val="000000"/>
+                      </a:solidFill>
+                      <a:prstDash val="solid"/>
+                      <a:round/>
+                      <a:headEnd type="none" w="med" len="med"/>
+                      <a:tailEnd type="none" w="med" len="med"/>
+                    </a:lnB>
+                    <a:noFill/>
+                  </a:tcPr>
+                </a:tc>
+                <a:tc>
+                  <a:txBody>
+                    <a:bodyPr/>
+                    <a:lstStyle/>
+                    <a:p>
+                      <a:pPr algn="ctr" fontAlgn="ctr">
+                        <a:buNone/>
+                      </a:pPr>
+                      <a:r>
+                        <a:rPr lang="en-US" sz="1600" b="0" i="0" u="none" strike="noStrike">
+                          <a:solidFill>
+                            <a:srgbClr val="000000"/>
+                          </a:solidFill>
+                          <a:effectLst/>
+                          <a:latin typeface="Aptos Narrow" panose="020B0004020202020204" pitchFamily="34" charset="0"/>
+                        </a:rPr>
+                        <a:t> </a:t>
+                      </a:r>
+                    </a:p>
+                  </a:txBody>
+                  <a:tcPr marL="9525" marR="9525" marT="9525" marB="0" anchor="ctr">
+                    <a:lnL w="6350" cap="flat" cmpd="sng" algn="ctr">
+                      <a:solidFill>
+                        <a:srgbClr val="000000"/>
+                      </a:solidFill>
+                      <a:prstDash val="solid"/>
+                      <a:round/>
+                      <a:headEnd type="none" w="med" len="med"/>
+                      <a:tailEnd type="none" w="med" len="med"/>
+                    </a:lnL>
+                    <a:lnR w="6350" cap="flat" cmpd="sng" algn="ctr">
+                      <a:solidFill>
+                        <a:srgbClr val="000000"/>
+                      </a:solidFill>
+                      <a:prstDash val="solid"/>
+                      <a:round/>
+                      <a:headEnd type="none" w="med" len="med"/>
+                      <a:tailEnd type="none" w="med" len="med"/>
+                    </a:lnR>
+                    <a:lnT w="12700" cap="flat" cmpd="sng" algn="ctr">
+                      <a:solidFill>
+                        <a:srgbClr val="000000"/>
+                      </a:solidFill>
+                      <a:prstDash val="solid"/>
+                      <a:round/>
+                      <a:headEnd type="none" w="med" len="med"/>
+                      <a:tailEnd type="none" w="med" len="med"/>
+                    </a:lnT>
+                    <a:lnB w="6350" cap="flat" cmpd="sng" algn="ctr">
+                      <a:solidFill>
+                        <a:srgbClr val="000000"/>
+                      </a:solidFill>
+                      <a:prstDash val="solid"/>
+                      <a:round/>
+                      <a:headEnd type="none" w="med" len="med"/>
+                      <a:tailEnd type="none" w="med" len="med"/>
+                    </a:lnB>
+                    <a:noFill/>
+                  </a:tcPr>
+                </a:tc>
+                <a:tc>
+                  <a:txBody>
+                    <a:bodyPr/>
+                    <a:lstStyle/>
+                    <a:p>
+                      <a:pPr algn="ctr" fontAlgn="ctr">
+                        <a:buNone/>
+                      </a:pPr>
+                      <a:r>
+                        <a:rPr lang="en-US" sz="1600" b="0" i="0" u="none" strike="noStrike" dirty="0">
+                          <a:solidFill>
+                            <a:srgbClr val="000000"/>
+                          </a:solidFill>
+                          <a:effectLst/>
+                          <a:latin typeface="Aptos Narrow" panose="020B0004020202020204" pitchFamily="34" charset="0"/>
+                        </a:rPr>
+                        <a:t> </a:t>
+                      </a:r>
+                    </a:p>
+                  </a:txBody>
+                  <a:tcPr marL="9525" marR="9525" marT="9525" marB="0" anchor="ctr">
+                    <a:lnL w="6350" cap="flat" cmpd="sng" algn="ctr">
+                      <a:solidFill>
+                        <a:srgbClr val="000000"/>
+                      </a:solidFill>
+                      <a:prstDash val="solid"/>
+                      <a:round/>
+                      <a:headEnd type="none" w="med" len="med"/>
+                      <a:tailEnd type="none" w="med" len="med"/>
+                    </a:lnL>
+                    <a:lnR w="6350" cap="flat" cmpd="sng" algn="ctr">
+                      <a:solidFill>
+                        <a:srgbClr val="000000"/>
+                      </a:solidFill>
+                      <a:prstDash val="solid"/>
+                      <a:round/>
+                      <a:headEnd type="none" w="med" len="med"/>
+                      <a:tailEnd type="none" w="med" len="med"/>
+                    </a:lnR>
+                    <a:lnT w="12700" cap="flat" cmpd="sng" algn="ctr">
+                      <a:solidFill>
+                        <a:srgbClr val="000000"/>
+                      </a:solidFill>
+                      <a:prstDash val="solid"/>
+                      <a:round/>
+                      <a:headEnd type="none" w="med" len="med"/>
+                      <a:tailEnd type="none" w="med" len="med"/>
+                    </a:lnT>
+                    <a:lnB w="6350" cap="flat" cmpd="sng" algn="ctr">
+                      <a:solidFill>
+                        <a:srgbClr val="000000"/>
+                      </a:solidFill>
+                      <a:prstDash val="solid"/>
+                      <a:round/>
+                      <a:headEnd type="none" w="med" len="med"/>
+                      <a:tailEnd type="none" w="med" len="med"/>
+                    </a:lnB>
+                    <a:noFill/>
+                  </a:tcPr>
+                </a:tc>
+                <a:tc>
+                  <a:txBody>
+                    <a:bodyPr/>
+                    <a:lstStyle/>
+                    <a:p>
+                      <a:pPr algn="l" fontAlgn="ctr">
+                        <a:buNone/>
+                      </a:pPr>
+                      <a:r>
+                        <a:rPr lang="en-US" sz="1600" b="0" i="0" u="none" strike="noStrike">
+                          <a:solidFill>
+                            <a:srgbClr val="000000"/>
+                          </a:solidFill>
+                          <a:effectLst/>
+                          <a:latin typeface="Aptos Narrow" panose="020B0004020202020204" pitchFamily="34" charset="0"/>
+                        </a:rPr>
+                        <a:t>Lightweight; very efficient small model</a:t>
+                      </a:r>
+                    </a:p>
+                  </a:txBody>
+                  <a:tcPr marL="9525" marR="9525" marT="9525" marB="0" anchor="ctr">
+                    <a:lnL w="6350" cap="flat" cmpd="sng" algn="ctr">
+                      <a:solidFill>
+                        <a:srgbClr val="000000"/>
+                      </a:solidFill>
+                      <a:prstDash val="solid"/>
+                      <a:round/>
+                      <a:headEnd type="none" w="med" len="med"/>
+                      <a:tailEnd type="none" w="med" len="med"/>
+                    </a:lnL>
+                    <a:lnR w="12700" cap="flat" cmpd="sng" algn="ctr">
+                      <a:solidFill>
+                        <a:srgbClr val="000000"/>
+                      </a:solidFill>
+                      <a:prstDash val="solid"/>
+                      <a:round/>
+                      <a:headEnd type="none" w="med" len="med"/>
+                      <a:tailEnd type="none" w="med" len="med"/>
+                    </a:lnR>
+                    <a:lnT w="12700" cap="flat" cmpd="sng" algn="ctr">
+                      <a:solidFill>
+                        <a:srgbClr val="000000"/>
+                      </a:solidFill>
+                      <a:prstDash val="solid"/>
+                      <a:round/>
+                      <a:headEnd type="none" w="med" len="med"/>
+                      <a:tailEnd type="none" w="med" len="med"/>
+                    </a:lnT>
+                    <a:lnB w="6350" cap="flat" cmpd="sng" algn="ctr">
+                      <a:solidFill>
+                        <a:srgbClr val="000000"/>
+                      </a:solidFill>
+                      <a:prstDash val="solid"/>
+                      <a:round/>
+                      <a:headEnd type="none" w="med" len="med"/>
+                      <a:tailEnd type="none" w="med" len="med"/>
+                    </a:lnB>
+                    <a:noFill/>
+                  </a:tcPr>
+                </a:tc>
+                <a:extLst>
+                  <a:ext uri="{0D108BD9-81ED-4DB2-BD59-A6C34878D82A}">
+                    <a16:rowId xmlns:a16="http://schemas.microsoft.com/office/drawing/2014/main" val="2540269638"/>
+                  </a:ext>
+                </a:extLst>
+              </a:tr>
+              <a:tr h="209550">
+                <a:tc vMerge="1">
+                  <a:txBody>
+                    <a:bodyPr/>
+                    <a:lstStyle/>
+                    <a:p>
+                      <a:endParaRPr lang="en-US"/>
+                    </a:p>
+                  </a:txBody>
+                  <a:tcPr/>
+                </a:tc>
+                <a:tc>
+                  <a:txBody>
+                    <a:bodyPr/>
+                    <a:lstStyle/>
+                    <a:p>
+                      <a:pPr algn="ctr" fontAlgn="ctr">
+                        <a:buNone/>
+                      </a:pPr>
+                      <a:r>
+                        <a:rPr lang="en-US" sz="1600" b="0" i="0" u="none" strike="noStrike">
+                          <a:solidFill>
+                            <a:srgbClr val="000000"/>
+                          </a:solidFill>
+                          <a:effectLst/>
+                          <a:latin typeface="Aptos Narrow" panose="020B0004020202020204" pitchFamily="34" charset="0"/>
+                        </a:rPr>
+                        <a:t>8B</a:t>
+                      </a:r>
+                    </a:p>
+                  </a:txBody>
+                  <a:tcPr marL="9525" marR="9525" marT="9525" marB="0" anchor="ctr">
+                    <a:lnL w="6350" cap="flat" cmpd="sng" algn="ctr">
+                      <a:solidFill>
+                        <a:srgbClr val="000000"/>
+                      </a:solidFill>
+                      <a:prstDash val="solid"/>
+                      <a:round/>
+                      <a:headEnd type="none" w="med" len="med"/>
+                      <a:tailEnd type="none" w="med" len="med"/>
+                    </a:lnL>
+                    <a:lnR w="6350" cap="flat" cmpd="sng" algn="ctr">
+                      <a:solidFill>
+                        <a:srgbClr val="000000"/>
+                      </a:solidFill>
+                      <a:prstDash val="solid"/>
+                      <a:round/>
+                      <a:headEnd type="none" w="med" len="med"/>
+                      <a:tailEnd type="none" w="med" len="med"/>
+                    </a:lnR>
+                    <a:lnT w="6350" cap="flat" cmpd="sng" algn="ctr">
+                      <a:solidFill>
+                        <a:srgbClr val="000000"/>
+                      </a:solidFill>
+                      <a:prstDash val="solid"/>
+                      <a:round/>
+                      <a:headEnd type="none" w="med" len="med"/>
+                      <a:tailEnd type="none" w="med" len="med"/>
+                    </a:lnT>
+                    <a:lnB w="12700" cap="flat" cmpd="sng" algn="ctr">
+                      <a:solidFill>
+                        <a:srgbClr val="000000"/>
+                      </a:solidFill>
+                      <a:prstDash val="solid"/>
+                      <a:round/>
+                      <a:headEnd type="none" w="med" len="med"/>
+                      <a:tailEnd type="none" w="med" len="med"/>
+                    </a:lnB>
+                    <a:noFill/>
+                  </a:tcPr>
+                </a:tc>
+                <a:tc>
+                  <a:txBody>
+                    <a:bodyPr/>
+                    <a:lstStyle/>
+                    <a:p>
+                      <a:pPr algn="ctr" fontAlgn="ctr">
+                        <a:buNone/>
+                      </a:pPr>
+                      <a:r>
+                        <a:rPr lang="en-US" sz="1600" b="0" i="0" u="none" strike="noStrike">
+                          <a:solidFill>
+                            <a:srgbClr val="000000"/>
+                          </a:solidFill>
+                          <a:effectLst/>
+                          <a:latin typeface="Aptos Narrow" panose="020B0004020202020204" pitchFamily="34" charset="0"/>
+                        </a:rPr>
+                        <a:t> </a:t>
+                      </a:r>
+                    </a:p>
+                  </a:txBody>
+                  <a:tcPr marL="9525" marR="9525" marT="9525" marB="0" anchor="ctr">
+                    <a:lnL w="6350" cap="flat" cmpd="sng" algn="ctr">
+                      <a:solidFill>
+                        <a:srgbClr val="000000"/>
+                      </a:solidFill>
+                      <a:prstDash val="solid"/>
+                      <a:round/>
+                      <a:headEnd type="none" w="med" len="med"/>
+                      <a:tailEnd type="none" w="med" len="med"/>
+                    </a:lnL>
+                    <a:lnR w="6350" cap="flat" cmpd="sng" algn="ctr">
+                      <a:solidFill>
+                        <a:srgbClr val="000000"/>
+                      </a:solidFill>
+                      <a:prstDash val="solid"/>
+                      <a:round/>
+                      <a:headEnd type="none" w="med" len="med"/>
+                      <a:tailEnd type="none" w="med" len="med"/>
+                    </a:lnR>
+                    <a:lnT w="6350" cap="flat" cmpd="sng" algn="ctr">
+                      <a:solidFill>
+                        <a:srgbClr val="000000"/>
+                      </a:solidFill>
+                      <a:prstDash val="solid"/>
+                      <a:round/>
+                      <a:headEnd type="none" w="med" len="med"/>
+                      <a:tailEnd type="none" w="med" len="med"/>
+                    </a:lnT>
+                    <a:lnB w="12700" cap="flat" cmpd="sng" algn="ctr">
+                      <a:solidFill>
+                        <a:srgbClr val="000000"/>
+                      </a:solidFill>
+                      <a:prstDash val="solid"/>
+                      <a:round/>
+                      <a:headEnd type="none" w="med" len="med"/>
+                      <a:tailEnd type="none" w="med" len="med"/>
+                    </a:lnB>
+                    <a:noFill/>
+                  </a:tcPr>
+                </a:tc>
+                <a:tc>
+                  <a:txBody>
+                    <a:bodyPr/>
+                    <a:lstStyle/>
+                    <a:p>
+                      <a:pPr algn="ctr" fontAlgn="ctr">
+                        <a:buNone/>
+                      </a:pPr>
+                      <a:r>
+                        <a:rPr lang="en-US" sz="1600" b="0" i="0" u="none" strike="noStrike" dirty="0">
+                          <a:solidFill>
+                            <a:srgbClr val="000000"/>
+                          </a:solidFill>
+                          <a:effectLst/>
+                          <a:latin typeface="Aptos Narrow" panose="020B0004020202020204" pitchFamily="34" charset="0"/>
+                        </a:rPr>
+                        <a:t> </a:t>
+                      </a:r>
+                    </a:p>
+                  </a:txBody>
+                  <a:tcPr marL="9525" marR="9525" marT="9525" marB="0" anchor="ctr">
+                    <a:lnL w="6350" cap="flat" cmpd="sng" algn="ctr">
+                      <a:solidFill>
+                        <a:srgbClr val="000000"/>
+                      </a:solidFill>
+                      <a:prstDash val="solid"/>
+                      <a:round/>
+                      <a:headEnd type="none" w="med" len="med"/>
+                      <a:tailEnd type="none" w="med" len="med"/>
+                    </a:lnL>
+                    <a:lnR w="6350" cap="flat" cmpd="sng" algn="ctr">
+                      <a:solidFill>
+                        <a:srgbClr val="000000"/>
+                      </a:solidFill>
+                      <a:prstDash val="solid"/>
+                      <a:round/>
+                      <a:headEnd type="none" w="med" len="med"/>
+                      <a:tailEnd type="none" w="med" len="med"/>
+                    </a:lnR>
+                    <a:lnT w="6350" cap="flat" cmpd="sng" algn="ctr">
+                      <a:solidFill>
+                        <a:srgbClr val="000000"/>
+                      </a:solidFill>
+                      <a:prstDash val="solid"/>
+                      <a:round/>
+                      <a:headEnd type="none" w="med" len="med"/>
+                      <a:tailEnd type="none" w="med" len="med"/>
+                    </a:lnT>
+                    <a:lnB w="12700" cap="flat" cmpd="sng" algn="ctr">
+                      <a:solidFill>
+                        <a:srgbClr val="000000"/>
+                      </a:solidFill>
+                      <a:prstDash val="solid"/>
+                      <a:round/>
+                      <a:headEnd type="none" w="med" len="med"/>
+                      <a:tailEnd type="none" w="med" len="med"/>
+                    </a:lnB>
+                    <a:noFill/>
+                  </a:tcPr>
+                </a:tc>
+                <a:tc>
+                  <a:txBody>
+                    <a:bodyPr/>
+                    <a:lstStyle/>
+                    <a:p>
+                      <a:pPr algn="l" fontAlgn="ctr">
+                        <a:buNone/>
+                      </a:pPr>
+                      <a:r>
+                        <a:rPr lang="en-US" sz="1600" b="0" i="0" u="none" strike="noStrike" dirty="0">
+                          <a:solidFill>
+                            <a:srgbClr val="000000"/>
+                          </a:solidFill>
+                          <a:effectLst/>
+                          <a:latin typeface="Aptos Narrow" panose="020B0004020202020204" pitchFamily="34" charset="0"/>
+                        </a:rPr>
+                        <a:t>Fast and stable; great quality-to-latency ratio</a:t>
+                      </a:r>
+                    </a:p>
+                  </a:txBody>
+                  <a:tcPr marL="9525" marR="9525" marT="9525" marB="0" anchor="ctr">
+                    <a:lnL w="6350" cap="flat" cmpd="sng" algn="ctr">
+                      <a:solidFill>
+                        <a:srgbClr val="000000"/>
+                      </a:solidFill>
+                      <a:prstDash val="solid"/>
+                      <a:round/>
+                      <a:headEnd type="none" w="med" len="med"/>
+                      <a:tailEnd type="none" w="med" len="med"/>
+                    </a:lnL>
+                    <a:lnR w="12700" cap="flat" cmpd="sng" algn="ctr">
+                      <a:solidFill>
+                        <a:srgbClr val="000000"/>
+                      </a:solidFill>
+                      <a:prstDash val="solid"/>
+                      <a:round/>
+                      <a:headEnd type="none" w="med" len="med"/>
+                      <a:tailEnd type="none" w="med" len="med"/>
+                    </a:lnR>
+                    <a:lnT w="6350" cap="flat" cmpd="sng" algn="ctr">
+                      <a:solidFill>
+                        <a:srgbClr val="000000"/>
+                      </a:solidFill>
+                      <a:prstDash val="solid"/>
+                      <a:round/>
+                      <a:headEnd type="none" w="med" len="med"/>
+                      <a:tailEnd type="none" w="med" len="med"/>
+                    </a:lnT>
+                    <a:lnB w="12700" cap="flat" cmpd="sng" algn="ctr">
+                      <a:solidFill>
+                        <a:srgbClr val="000000"/>
+                      </a:solidFill>
+                      <a:prstDash val="solid"/>
+                      <a:round/>
+                      <a:headEnd type="none" w="med" len="med"/>
+                      <a:tailEnd type="none" w="med" len="med"/>
+                    </a:lnB>
+                    <a:noFill/>
+                  </a:tcPr>
+                </a:tc>
+                <a:extLst>
+                  <a:ext uri="{0D108BD9-81ED-4DB2-BD59-A6C34878D82A}">
+                    <a16:rowId xmlns:a16="http://schemas.microsoft.com/office/drawing/2014/main" val="2564042992"/>
+                  </a:ext>
+                </a:extLst>
+              </a:tr>
+              <a:tr h="200025">
+                <a:tc rowSpan="2">
+                  <a:txBody>
+                    <a:bodyPr/>
+                    <a:lstStyle/>
+                    <a:p>
+                      <a:pPr algn="ctr" fontAlgn="ctr">
+                        <a:buNone/>
+                      </a:pPr>
+                      <a:r>
+                        <a:rPr lang="en-US" sz="1600" b="1" i="0" u="none" strike="noStrike">
+                          <a:solidFill>
+                            <a:srgbClr val="000000"/>
+                          </a:solidFill>
+                          <a:effectLst/>
+                          <a:latin typeface="Aptos Narrow" panose="020B0004020202020204" pitchFamily="34" charset="0"/>
+                        </a:rPr>
+                        <a:t>Gemma 3</a:t>
+                      </a:r>
+                    </a:p>
+                  </a:txBody>
+                  <a:tcPr marL="9525" marR="9525" marT="9525" marB="0" anchor="ctr">
+                    <a:lnL w="12700" cap="flat" cmpd="sng" algn="ctr">
+                      <a:solidFill>
+                        <a:srgbClr val="000000"/>
+                      </a:solidFill>
+                      <a:prstDash val="solid"/>
+                      <a:round/>
+                      <a:headEnd type="none" w="med" len="med"/>
+                      <a:tailEnd type="none" w="med" len="med"/>
+                    </a:lnL>
+                    <a:lnR w="6350" cap="flat" cmpd="sng" algn="ctr">
+                      <a:solidFill>
+                        <a:srgbClr val="000000"/>
+                      </a:solidFill>
+                      <a:prstDash val="solid"/>
+                      <a:round/>
+                      <a:headEnd type="none" w="med" len="med"/>
+                      <a:tailEnd type="none" w="med" len="med"/>
+                    </a:lnR>
+                    <a:lnT w="12700" cap="flat" cmpd="sng" algn="ctr">
+                      <a:solidFill>
+                        <a:srgbClr val="000000"/>
+                      </a:solidFill>
+                      <a:prstDash val="solid"/>
+                      <a:round/>
+                      <a:headEnd type="none" w="med" len="med"/>
+                      <a:tailEnd type="none" w="med" len="med"/>
+                    </a:lnT>
+                    <a:lnB w="12700" cap="flat" cmpd="sng" algn="ctr">
+                      <a:solidFill>
+                        <a:srgbClr val="000000"/>
+                      </a:solidFill>
+                      <a:prstDash val="solid"/>
+                      <a:round/>
+                      <a:headEnd type="none" w="med" len="med"/>
+                      <a:tailEnd type="none" w="med" len="med"/>
+                    </a:lnB>
+                    <a:noFill/>
+                  </a:tcPr>
+                </a:tc>
+                <a:tc>
+                  <a:txBody>
+                    <a:bodyPr/>
+                    <a:lstStyle/>
+                    <a:p>
+                      <a:pPr algn="ctr" fontAlgn="ctr">
+                        <a:buNone/>
+                      </a:pPr>
+                      <a:r>
+                        <a:rPr lang="en-US" sz="1600" b="0" i="0" u="none" strike="noStrike">
+                          <a:solidFill>
+                            <a:srgbClr val="000000"/>
+                          </a:solidFill>
+                          <a:effectLst/>
+                          <a:latin typeface="Aptos Narrow" panose="020B0004020202020204" pitchFamily="34" charset="0"/>
+                        </a:rPr>
+                        <a:t>12B</a:t>
+                      </a:r>
+                    </a:p>
+                  </a:txBody>
+                  <a:tcPr marL="9525" marR="9525" marT="9525" marB="0" anchor="ctr">
+                    <a:lnL w="6350" cap="flat" cmpd="sng" algn="ctr">
+                      <a:solidFill>
+                        <a:srgbClr val="000000"/>
+                      </a:solidFill>
+                      <a:prstDash val="solid"/>
+                      <a:round/>
+                      <a:headEnd type="none" w="med" len="med"/>
+                      <a:tailEnd type="none" w="med" len="med"/>
+                    </a:lnL>
+                    <a:lnR w="6350" cap="flat" cmpd="sng" algn="ctr">
+                      <a:solidFill>
+                        <a:srgbClr val="000000"/>
+                      </a:solidFill>
+                      <a:prstDash val="solid"/>
+                      <a:round/>
+                      <a:headEnd type="none" w="med" len="med"/>
+                      <a:tailEnd type="none" w="med" len="med"/>
+                    </a:lnR>
+                    <a:lnT w="12700" cap="flat" cmpd="sng" algn="ctr">
+                      <a:solidFill>
+                        <a:srgbClr val="000000"/>
+                      </a:solidFill>
+                      <a:prstDash val="solid"/>
+                      <a:round/>
+                      <a:headEnd type="none" w="med" len="med"/>
+                      <a:tailEnd type="none" w="med" len="med"/>
+                    </a:lnT>
+                    <a:lnB w="6350" cap="flat" cmpd="sng" algn="ctr">
+                      <a:solidFill>
+                        <a:srgbClr val="000000"/>
+                      </a:solidFill>
+                      <a:prstDash val="solid"/>
+                      <a:round/>
+                      <a:headEnd type="none" w="med" len="med"/>
+                      <a:tailEnd type="none" w="med" len="med"/>
+                    </a:lnB>
+                    <a:noFill/>
+                  </a:tcPr>
+                </a:tc>
+                <a:tc>
+                  <a:txBody>
+                    <a:bodyPr/>
+                    <a:lstStyle/>
+                    <a:p>
+                      <a:pPr algn="ctr" fontAlgn="ctr">
+                        <a:buNone/>
+                      </a:pPr>
+                      <a:r>
+                        <a:rPr lang="en-US" sz="1600" b="0" i="0" u="none" strike="noStrike">
+                          <a:solidFill>
+                            <a:srgbClr val="000000"/>
+                          </a:solidFill>
+                          <a:effectLst/>
+                          <a:latin typeface="Aptos Narrow" panose="020B0004020202020204" pitchFamily="34" charset="0"/>
+                        </a:rPr>
+                        <a:t> </a:t>
+                      </a:r>
+                    </a:p>
+                  </a:txBody>
+                  <a:tcPr marL="9525" marR="9525" marT="9525" marB="0" anchor="ctr">
+                    <a:lnL w="6350" cap="flat" cmpd="sng" algn="ctr">
+                      <a:solidFill>
+                        <a:srgbClr val="000000"/>
+                      </a:solidFill>
+                      <a:prstDash val="solid"/>
+                      <a:round/>
+                      <a:headEnd type="none" w="med" len="med"/>
+                      <a:tailEnd type="none" w="med" len="med"/>
+                    </a:lnL>
+                    <a:lnR w="6350" cap="flat" cmpd="sng" algn="ctr">
+                      <a:solidFill>
+                        <a:srgbClr val="000000"/>
+                      </a:solidFill>
+                      <a:prstDash val="solid"/>
+                      <a:round/>
+                      <a:headEnd type="none" w="med" len="med"/>
+                      <a:tailEnd type="none" w="med" len="med"/>
+                    </a:lnR>
+                    <a:lnT w="12700" cap="flat" cmpd="sng" algn="ctr">
+                      <a:solidFill>
+                        <a:srgbClr val="000000"/>
+                      </a:solidFill>
+                      <a:prstDash val="solid"/>
+                      <a:round/>
+                      <a:headEnd type="none" w="med" len="med"/>
+                      <a:tailEnd type="none" w="med" len="med"/>
+                    </a:lnT>
+                    <a:lnB w="6350" cap="flat" cmpd="sng" algn="ctr">
+                      <a:solidFill>
+                        <a:srgbClr val="000000"/>
+                      </a:solidFill>
+                      <a:prstDash val="solid"/>
+                      <a:round/>
+                      <a:headEnd type="none" w="med" len="med"/>
+                      <a:tailEnd type="none" w="med" len="med"/>
+                    </a:lnB>
+                    <a:noFill/>
+                  </a:tcPr>
+                </a:tc>
+                <a:tc>
+                  <a:txBody>
+                    <a:bodyPr/>
+                    <a:lstStyle/>
+                    <a:p>
+                      <a:pPr algn="ctr" fontAlgn="ctr">
+                        <a:buNone/>
+                      </a:pPr>
+                      <a:r>
+                        <a:rPr lang="en-US" sz="1600" b="0" i="0" u="none" strike="noStrike" dirty="0">
+                          <a:solidFill>
+                            <a:srgbClr val="000000"/>
+                          </a:solidFill>
+                          <a:effectLst/>
+                          <a:latin typeface="Aptos Narrow" panose="020B0004020202020204" pitchFamily="34" charset="0"/>
+                        </a:rPr>
+                        <a:t> </a:t>
+                      </a:r>
+                    </a:p>
+                  </a:txBody>
+                  <a:tcPr marL="9525" marR="9525" marT="9525" marB="0" anchor="ctr">
+                    <a:lnL w="6350" cap="flat" cmpd="sng" algn="ctr">
+                      <a:solidFill>
+                        <a:srgbClr val="000000"/>
+                      </a:solidFill>
+                      <a:prstDash val="solid"/>
+                      <a:round/>
+                      <a:headEnd type="none" w="med" len="med"/>
+                      <a:tailEnd type="none" w="med" len="med"/>
+                    </a:lnL>
+                    <a:lnR w="6350" cap="flat" cmpd="sng" algn="ctr">
+                      <a:solidFill>
+                        <a:srgbClr val="000000"/>
+                      </a:solidFill>
+                      <a:prstDash val="solid"/>
+                      <a:round/>
+                      <a:headEnd type="none" w="med" len="med"/>
+                      <a:tailEnd type="none" w="med" len="med"/>
+                    </a:lnR>
+                    <a:lnT w="12700" cap="flat" cmpd="sng" algn="ctr">
+                      <a:solidFill>
+                        <a:srgbClr val="000000"/>
+                      </a:solidFill>
+                      <a:prstDash val="solid"/>
+                      <a:round/>
+                      <a:headEnd type="none" w="med" len="med"/>
+                      <a:tailEnd type="none" w="med" len="med"/>
+                    </a:lnT>
+                    <a:lnB w="6350" cap="flat" cmpd="sng" algn="ctr">
+                      <a:solidFill>
+                        <a:srgbClr val="000000"/>
+                      </a:solidFill>
+                      <a:prstDash val="solid"/>
+                      <a:round/>
+                      <a:headEnd type="none" w="med" len="med"/>
+                      <a:tailEnd type="none" w="med" len="med"/>
+                    </a:lnB>
+                    <a:noFill/>
+                  </a:tcPr>
+                </a:tc>
+                <a:tc>
+                  <a:txBody>
+                    <a:bodyPr/>
+                    <a:lstStyle/>
+                    <a:p>
+                      <a:pPr algn="l" fontAlgn="ctr">
+                        <a:buNone/>
+                      </a:pPr>
+                      <a:r>
+                        <a:rPr lang="en-US" sz="1600" b="0" i="0" u="none" strike="noStrike" dirty="0">
+                          <a:solidFill>
+                            <a:srgbClr val="000000"/>
+                          </a:solidFill>
+                          <a:effectLst/>
+                          <a:latin typeface="Aptos Narrow" panose="020B0004020202020204" pitchFamily="34" charset="0"/>
+                        </a:rPr>
+                        <a:t>Reliable mid-range model</a:t>
+                      </a:r>
+                    </a:p>
+                  </a:txBody>
+                  <a:tcPr marL="9525" marR="9525" marT="9525" marB="0" anchor="ctr">
+                    <a:lnL w="6350" cap="flat" cmpd="sng" algn="ctr">
+                      <a:solidFill>
+                        <a:srgbClr val="000000"/>
+                      </a:solidFill>
+                      <a:prstDash val="solid"/>
+                      <a:round/>
+                      <a:headEnd type="none" w="med" len="med"/>
+                      <a:tailEnd type="none" w="med" len="med"/>
+                    </a:lnL>
+                    <a:lnR w="12700" cap="flat" cmpd="sng" algn="ctr">
+                      <a:solidFill>
+                        <a:srgbClr val="000000"/>
+                      </a:solidFill>
+                      <a:prstDash val="solid"/>
+                      <a:round/>
+                      <a:headEnd type="none" w="med" len="med"/>
+                      <a:tailEnd type="none" w="med" len="med"/>
+                    </a:lnR>
+                    <a:lnT w="12700" cap="flat" cmpd="sng" algn="ctr">
+                      <a:solidFill>
+                        <a:srgbClr val="000000"/>
+                      </a:solidFill>
+                      <a:prstDash val="solid"/>
+                      <a:round/>
+                      <a:headEnd type="none" w="med" len="med"/>
+                      <a:tailEnd type="none" w="med" len="med"/>
+                    </a:lnT>
+                    <a:lnB w="6350" cap="flat" cmpd="sng" algn="ctr">
+                      <a:solidFill>
+                        <a:srgbClr val="000000"/>
+                      </a:solidFill>
+                      <a:prstDash val="solid"/>
+                      <a:round/>
+                      <a:headEnd type="none" w="med" len="med"/>
+                      <a:tailEnd type="none" w="med" len="med"/>
+                    </a:lnB>
+                    <a:noFill/>
+                  </a:tcPr>
+                </a:tc>
+                <a:extLst>
+                  <a:ext uri="{0D108BD9-81ED-4DB2-BD59-A6C34878D82A}">
+                    <a16:rowId xmlns:a16="http://schemas.microsoft.com/office/drawing/2014/main" val="4161983873"/>
+                  </a:ext>
+                </a:extLst>
+              </a:tr>
+              <a:tr h="209550">
+                <a:tc vMerge="1">
+                  <a:txBody>
+                    <a:bodyPr/>
+                    <a:lstStyle/>
+                    <a:p>
+                      <a:endParaRPr lang="en-US"/>
+                    </a:p>
+                  </a:txBody>
+                  <a:tcPr/>
+                </a:tc>
+                <a:tc>
+                  <a:txBody>
+                    <a:bodyPr/>
+                    <a:lstStyle/>
+                    <a:p>
+                      <a:pPr algn="ctr" fontAlgn="ctr">
+                        <a:buNone/>
+                      </a:pPr>
+                      <a:r>
+                        <a:rPr lang="en-US" sz="1600" b="0" i="0" u="none" strike="noStrike">
+                          <a:solidFill>
+                            <a:srgbClr val="000000"/>
+                          </a:solidFill>
+                          <a:effectLst/>
+                          <a:latin typeface="Aptos Narrow" panose="020B0004020202020204" pitchFamily="34" charset="0"/>
+                        </a:rPr>
+                        <a:t>27B</a:t>
+                      </a:r>
+                    </a:p>
+                  </a:txBody>
+                  <a:tcPr marL="9525" marR="9525" marT="9525" marB="0" anchor="ctr">
+                    <a:lnL w="6350" cap="flat" cmpd="sng" algn="ctr">
+                      <a:solidFill>
+                        <a:srgbClr val="000000"/>
+                      </a:solidFill>
+                      <a:prstDash val="solid"/>
+                      <a:round/>
+                      <a:headEnd type="none" w="med" len="med"/>
+                      <a:tailEnd type="none" w="med" len="med"/>
+                    </a:lnL>
+                    <a:lnR w="6350" cap="flat" cmpd="sng" algn="ctr">
+                      <a:solidFill>
+                        <a:srgbClr val="000000"/>
+                      </a:solidFill>
+                      <a:prstDash val="solid"/>
+                      <a:round/>
+                      <a:headEnd type="none" w="med" len="med"/>
+                      <a:tailEnd type="none" w="med" len="med"/>
+                    </a:lnR>
+                    <a:lnT w="6350" cap="flat" cmpd="sng" algn="ctr">
+                      <a:solidFill>
+                        <a:srgbClr val="000000"/>
+                      </a:solidFill>
+                      <a:prstDash val="solid"/>
+                      <a:round/>
+                      <a:headEnd type="none" w="med" len="med"/>
+                      <a:tailEnd type="none" w="med" len="med"/>
+                    </a:lnT>
+                    <a:lnB w="12700" cap="flat" cmpd="sng" algn="ctr">
+                      <a:solidFill>
+                        <a:srgbClr val="000000"/>
+                      </a:solidFill>
+                      <a:prstDash val="solid"/>
+                      <a:round/>
+                      <a:headEnd type="none" w="med" len="med"/>
+                      <a:tailEnd type="none" w="med" len="med"/>
+                    </a:lnB>
+                    <a:noFill/>
+                  </a:tcPr>
+                </a:tc>
+                <a:tc>
+                  <a:txBody>
+                    <a:bodyPr/>
+                    <a:lstStyle/>
+                    <a:p>
+                      <a:pPr algn="ctr" fontAlgn="ctr">
+                        <a:buNone/>
+                      </a:pPr>
+                      <a:r>
+                        <a:rPr lang="en-US" sz="1600" b="0" i="0" u="none" strike="noStrike">
+                          <a:solidFill>
+                            <a:srgbClr val="000000"/>
+                          </a:solidFill>
+                          <a:effectLst/>
+                          <a:latin typeface="Aptos Narrow" panose="020B0004020202020204" pitchFamily="34" charset="0"/>
+                        </a:rPr>
+                        <a:t> </a:t>
+                      </a:r>
+                    </a:p>
+                  </a:txBody>
+                  <a:tcPr marL="9525" marR="9525" marT="9525" marB="0" anchor="ctr">
+                    <a:lnL w="6350" cap="flat" cmpd="sng" algn="ctr">
+                      <a:solidFill>
+                        <a:srgbClr val="000000"/>
+                      </a:solidFill>
+                      <a:prstDash val="solid"/>
+                      <a:round/>
+                      <a:headEnd type="none" w="med" len="med"/>
+                      <a:tailEnd type="none" w="med" len="med"/>
+                    </a:lnL>
+                    <a:lnR w="6350" cap="flat" cmpd="sng" algn="ctr">
+                      <a:solidFill>
+                        <a:srgbClr val="000000"/>
+                      </a:solidFill>
+                      <a:prstDash val="solid"/>
+                      <a:round/>
+                      <a:headEnd type="none" w="med" len="med"/>
+                      <a:tailEnd type="none" w="med" len="med"/>
+                    </a:lnR>
+                    <a:lnT w="6350" cap="flat" cmpd="sng" algn="ctr">
+                      <a:solidFill>
+                        <a:srgbClr val="000000"/>
+                      </a:solidFill>
+                      <a:prstDash val="solid"/>
+                      <a:round/>
+                      <a:headEnd type="none" w="med" len="med"/>
+                      <a:tailEnd type="none" w="med" len="med"/>
+                    </a:lnT>
+                    <a:lnB w="12700" cap="flat" cmpd="sng" algn="ctr">
+                      <a:solidFill>
+                        <a:srgbClr val="000000"/>
+                      </a:solidFill>
+                      <a:prstDash val="solid"/>
+                      <a:round/>
+                      <a:headEnd type="none" w="med" len="med"/>
+                      <a:tailEnd type="none" w="med" len="med"/>
+                    </a:lnB>
+                    <a:noFill/>
+                  </a:tcPr>
+                </a:tc>
+                <a:tc>
+                  <a:txBody>
+                    <a:bodyPr/>
+                    <a:lstStyle/>
+                    <a:p>
+                      <a:pPr algn="ctr" fontAlgn="ctr">
+                        <a:buNone/>
+                      </a:pPr>
+                      <a:r>
+                        <a:rPr lang="en-US" sz="1600" b="0" i="0" u="none" strike="noStrike" dirty="0">
+                          <a:solidFill>
+                            <a:srgbClr val="000000"/>
+                          </a:solidFill>
+                          <a:effectLst/>
+                          <a:latin typeface="Aptos Narrow" panose="020B0004020202020204" pitchFamily="34" charset="0"/>
+                        </a:rPr>
+                        <a:t> </a:t>
+                      </a:r>
+                    </a:p>
+                  </a:txBody>
+                  <a:tcPr marL="9525" marR="9525" marT="9525" marB="0" anchor="ctr">
+                    <a:lnL w="6350" cap="flat" cmpd="sng" algn="ctr">
+                      <a:solidFill>
+                        <a:srgbClr val="000000"/>
+                      </a:solidFill>
+                      <a:prstDash val="solid"/>
+                      <a:round/>
+                      <a:headEnd type="none" w="med" len="med"/>
+                      <a:tailEnd type="none" w="med" len="med"/>
+                    </a:lnL>
+                    <a:lnR w="6350" cap="flat" cmpd="sng" algn="ctr">
+                      <a:solidFill>
+                        <a:srgbClr val="000000"/>
+                      </a:solidFill>
+                      <a:prstDash val="solid"/>
+                      <a:round/>
+                      <a:headEnd type="none" w="med" len="med"/>
+                      <a:tailEnd type="none" w="med" len="med"/>
+                    </a:lnR>
+                    <a:lnT w="6350" cap="flat" cmpd="sng" algn="ctr">
+                      <a:solidFill>
+                        <a:srgbClr val="000000"/>
+                      </a:solidFill>
+                      <a:prstDash val="solid"/>
+                      <a:round/>
+                      <a:headEnd type="none" w="med" len="med"/>
+                      <a:tailEnd type="none" w="med" len="med"/>
+                    </a:lnT>
+                    <a:lnB w="12700" cap="flat" cmpd="sng" algn="ctr">
+                      <a:solidFill>
+                        <a:srgbClr val="000000"/>
+                      </a:solidFill>
+                      <a:prstDash val="solid"/>
+                      <a:round/>
+                      <a:headEnd type="none" w="med" len="med"/>
+                      <a:tailEnd type="none" w="med" len="med"/>
+                    </a:lnB>
+                    <a:noFill/>
+                  </a:tcPr>
+                </a:tc>
+                <a:tc>
+                  <a:txBody>
+                    <a:bodyPr/>
+                    <a:lstStyle/>
+                    <a:p>
+                      <a:pPr algn="l" fontAlgn="ctr">
+                        <a:buNone/>
+                      </a:pPr>
+                      <a:r>
+                        <a:rPr lang="en-US" sz="1600" b="0" i="0" u="none" strike="noStrike" dirty="0">
+                          <a:solidFill>
+                            <a:srgbClr val="000000"/>
+                          </a:solidFill>
+                          <a:effectLst/>
+                          <a:latin typeface="Aptos Narrow" panose="020B0004020202020204" pitchFamily="34" charset="0"/>
+                        </a:rPr>
+                        <a:t>Good quality but slower due to size</a:t>
+                      </a:r>
+                    </a:p>
+                  </a:txBody>
+                  <a:tcPr marL="9525" marR="9525" marT="9525" marB="0" anchor="ctr">
+                    <a:lnL w="6350" cap="flat" cmpd="sng" algn="ctr">
+                      <a:solidFill>
+                        <a:srgbClr val="000000"/>
+                      </a:solidFill>
+                      <a:prstDash val="solid"/>
+                      <a:round/>
+                      <a:headEnd type="none" w="med" len="med"/>
+                      <a:tailEnd type="none" w="med" len="med"/>
+                    </a:lnL>
+                    <a:lnR w="12700" cap="flat" cmpd="sng" algn="ctr">
+                      <a:solidFill>
+                        <a:srgbClr val="000000"/>
+                      </a:solidFill>
+                      <a:prstDash val="solid"/>
+                      <a:round/>
+                      <a:headEnd type="none" w="med" len="med"/>
+                      <a:tailEnd type="none" w="med" len="med"/>
+                    </a:lnR>
+                    <a:lnT w="6350" cap="flat" cmpd="sng" algn="ctr">
+                      <a:solidFill>
+                        <a:srgbClr val="000000"/>
+                      </a:solidFill>
+                      <a:prstDash val="solid"/>
+                      <a:round/>
+                      <a:headEnd type="none" w="med" len="med"/>
+                      <a:tailEnd type="none" w="med" len="med"/>
+                    </a:lnT>
+                    <a:lnB w="12700" cap="flat" cmpd="sng" algn="ctr">
+                      <a:solidFill>
+                        <a:srgbClr val="000000"/>
+                      </a:solidFill>
+                      <a:prstDash val="solid"/>
+                      <a:round/>
+                      <a:headEnd type="none" w="med" len="med"/>
+                      <a:tailEnd type="none" w="med" len="med"/>
+                    </a:lnB>
+                    <a:noFill/>
+                  </a:tcPr>
+                </a:tc>
+                <a:extLst>
+                  <a:ext uri="{0D108BD9-81ED-4DB2-BD59-A6C34878D82A}">
+                    <a16:rowId xmlns:a16="http://schemas.microsoft.com/office/drawing/2014/main" val="1466274687"/>
+                  </a:ext>
+                </a:extLst>
+              </a:tr>
+            </a:tbl>
+          </a:graphicData>
+        </a:graphic>
+      </p:graphicFrame>
     </p:spTree>
     <p:extLst>
       <p:ext uri="{BB962C8B-B14F-4D97-AF65-F5344CB8AC3E}">
@@ -20022,118 +22090,6 @@
 </file>
 
 <file path=ppt/slides/slide12.xml><?xml version="1.0" encoding="utf-8"?>
-<p:sld xmlns:a="http://schemas.openxmlformats.org/drawingml/2006/main" xmlns:r="http://schemas.openxmlformats.org/officeDocument/2006/relationships" xmlns:p="http://schemas.openxmlformats.org/presentationml/2006/main">
-  <p:cSld>
-    <p:spTree>
-      <p:nvGrpSpPr>
-        <p:cNvPr id="1" name=""/>
-        <p:cNvGrpSpPr/>
-        <p:nvPr/>
-      </p:nvGrpSpPr>
-      <p:grpSpPr>
-        <a:xfrm>
-          <a:off x="0" y="0"/>
-          <a:ext cx="0" cy="0"/>
-          <a:chOff x="0" y="0"/>
-          <a:chExt cx="0" cy="0"/>
-        </a:xfrm>
-      </p:grpSpPr>
-      <p:sp>
-        <p:nvSpPr>
-          <p:cNvPr id="2" name="Title 1">
-            <a:extLst>
-              <a:ext uri="{FF2B5EF4-FFF2-40B4-BE49-F238E27FC236}">
-                <a16:creationId xmlns:a16="http://schemas.microsoft.com/office/drawing/2014/main" id="{22A28C1A-9EEA-787E-E7A2-1F5D8E39B4E6}"/>
-              </a:ext>
-            </a:extLst>
-          </p:cNvPr>
-          <p:cNvSpPr>
-            <a:spLocks noGrp="1"/>
-          </p:cNvSpPr>
-          <p:nvPr>
-            <p:ph type="title"/>
-          </p:nvPr>
-        </p:nvSpPr>
-        <p:spPr/>
-        <p:txBody>
-          <a:bodyPr/>
-          <a:lstStyle/>
-          <a:p>
-            <a:r>
-              <a:rPr lang="en-US" dirty="0"/>
-              <a:t>Infrastructure: Hardware</a:t>
-            </a:r>
-          </a:p>
-        </p:txBody>
-      </p:sp>
-      <p:sp>
-        <p:nvSpPr>
-          <p:cNvPr id="3" name="Content Placeholder 2">
-            <a:extLst>
-              <a:ext uri="{FF2B5EF4-FFF2-40B4-BE49-F238E27FC236}">
-                <a16:creationId xmlns:a16="http://schemas.microsoft.com/office/drawing/2014/main" id="{E49E6847-9123-9CE6-74F8-51BB2AB869B3}"/>
-              </a:ext>
-            </a:extLst>
-          </p:cNvPr>
-          <p:cNvSpPr>
-            <a:spLocks noGrp="1"/>
-          </p:cNvSpPr>
-          <p:nvPr>
-            <p:ph sz="quarter" idx="13"/>
-          </p:nvPr>
-        </p:nvSpPr>
-        <p:spPr/>
-        <p:txBody>
-          <a:bodyPr/>
-          <a:lstStyle/>
-          <a:p>
-            <a:endParaRPr lang="en-US" dirty="0"/>
-          </a:p>
-        </p:txBody>
-      </p:sp>
-      <p:sp>
-        <p:nvSpPr>
-          <p:cNvPr id="4" name="Slide Number Placeholder 3">
-            <a:extLst>
-              <a:ext uri="{FF2B5EF4-FFF2-40B4-BE49-F238E27FC236}">
-                <a16:creationId xmlns:a16="http://schemas.microsoft.com/office/drawing/2014/main" id="{E3851BDF-8F9D-462A-E519-41432856F554}"/>
-              </a:ext>
-            </a:extLst>
-          </p:cNvPr>
-          <p:cNvSpPr>
-            <a:spLocks noGrp="1"/>
-          </p:cNvSpPr>
-          <p:nvPr>
-            <p:ph type="sldNum" sz="quarter" idx="16"/>
-          </p:nvPr>
-        </p:nvSpPr>
-        <p:spPr/>
-        <p:txBody>
-          <a:bodyPr/>
-          <a:lstStyle/>
-          <a:p>
-            <a:fld id="{A2D3FCAD-823A-476E-8B64-08133BA4013A}" type="slidenum">
-              <a:rPr lang="en-US" smtClean="0"/>
-              <a:t>12</a:t>
-            </a:fld>
-            <a:endParaRPr lang="en-US"/>
-          </a:p>
-        </p:txBody>
-      </p:sp>
-    </p:spTree>
-    <p:extLst>
-      <p:ext uri="{BB962C8B-B14F-4D97-AF65-F5344CB8AC3E}">
-        <p14:creationId xmlns:p14="http://schemas.microsoft.com/office/powerpoint/2010/main" val="2290738834"/>
-      </p:ext>
-    </p:extLst>
-  </p:cSld>
-  <p:clrMapOvr>
-    <a:masterClrMapping/>
-  </p:clrMapOvr>
-</p:sld>
-</file>
-
-<file path=ppt/slides/slide13.xml><?xml version="1.0" encoding="utf-8"?>
 <p:sld xmlns:a="http://schemas.openxmlformats.org/drawingml/2006/main" xmlns:r="http://schemas.openxmlformats.org/officeDocument/2006/relationships" xmlns:p="http://schemas.openxmlformats.org/presentationml/2006/main">
   <p:cSld>
     <p:spTree>
@@ -20202,10 +22158,114 @@
         </p:nvSpPr>
         <p:spPr/>
         <p:txBody>
-          <a:bodyPr/>
+          <a:bodyPr>
+            <a:normAutofit/>
+          </a:bodyPr>
           <a:lstStyle/>
           <a:p>
+            <a:r>
+              <a:rPr lang="en-US" b="1" dirty="0"/>
+              <a:t>DNS Configuration</a:t>
+            </a:r>
             <a:endParaRPr lang="en-US" dirty="0"/>
+          </a:p>
+          <a:p>
+            <a:pPr lvl="1"/>
+            <a:r>
+              <a:rPr lang="en-US" dirty="0"/>
+              <a:t>Set up a custom DNS record to point clients (local + remote) to the home server</a:t>
+            </a:r>
+          </a:p>
+          <a:p>
+            <a:pPr lvl="1"/>
+            <a:r>
+              <a:rPr lang="en-US" dirty="0"/>
+              <a:t>Wrote a shell script to automatically update the DNS record whenever the public IP changes</a:t>
+            </a:r>
+          </a:p>
+          <a:p>
+            <a:pPr lvl="1"/>
+            <a:r>
+              <a:rPr lang="en-US" dirty="0">
+                <a:hlinkClick r:id="rId2"/>
+              </a:rPr>
+              <a:t>https://ollama.loweffort.meme</a:t>
+            </a:r>
+            <a:endParaRPr lang="en-US" dirty="0"/>
+          </a:p>
+          <a:p>
+            <a:endParaRPr lang="en-US" b="1" dirty="0"/>
+          </a:p>
+          <a:p>
+            <a:r>
+              <a:rPr lang="en-US" b="1" dirty="0"/>
+              <a:t>Caddy Reverse Proxy</a:t>
+            </a:r>
+            <a:endParaRPr lang="en-US" dirty="0"/>
+          </a:p>
+          <a:p>
+            <a:pPr lvl="1"/>
+            <a:r>
+              <a:rPr lang="en-US" dirty="0"/>
+              <a:t>Configured Caddy to handle HTTPS termination and route traffic to the </a:t>
+            </a:r>
+            <a:r>
+              <a:rPr lang="en-US" dirty="0" err="1"/>
+              <a:t>Ollama</a:t>
+            </a:r>
+            <a:r>
+              <a:rPr lang="en-US" dirty="0"/>
+              <a:t> backend</a:t>
+            </a:r>
+          </a:p>
+          <a:p>
+            <a:pPr lvl="1"/>
+            <a:r>
+              <a:rPr lang="en-US" dirty="0"/>
+              <a:t>Set up automatic startup on boot to ensure the AI service stays available</a:t>
+            </a:r>
+          </a:p>
+          <a:p>
+            <a:pPr lvl="1"/>
+            <a:r>
+              <a:rPr lang="en-US" dirty="0"/>
+              <a:t>Handles remote access safely without manual port forwarding management</a:t>
+            </a:r>
+          </a:p>
+          <a:p>
+            <a:endParaRPr lang="en-US" b="1" dirty="0"/>
+          </a:p>
+          <a:p>
+            <a:r>
+              <a:rPr lang="en-US" b="1" dirty="0" err="1"/>
+              <a:t>Ollama</a:t>
+            </a:r>
+            <a:r>
+              <a:rPr lang="en-US" b="1" dirty="0"/>
+              <a:t> Server</a:t>
+            </a:r>
+            <a:endParaRPr lang="en-US" dirty="0"/>
+          </a:p>
+          <a:p>
+            <a:pPr lvl="1"/>
+            <a:r>
+              <a:rPr lang="en-US" dirty="0"/>
+              <a:t>Hosted multiple models (4B–120B scale) on the dedicated machine</a:t>
+            </a:r>
+          </a:p>
+          <a:p>
+            <a:pPr lvl="1"/>
+            <a:r>
+              <a:rPr lang="en-US" dirty="0"/>
+              <a:t>Configured to start automatically at system boot for uninterrupted benchmarking</a:t>
+            </a:r>
+          </a:p>
+          <a:p>
+            <a:pPr lvl="1"/>
+            <a:r>
+              <a:rPr lang="en-US" dirty="0"/>
+              <a:t>Future upgrade: add API key authentication for controlled remote access</a:t>
+            </a:r>
           </a:p>
         </p:txBody>
       </p:sp>
@@ -20232,7 +22292,7 @@
           <a:p>
             <a:fld id="{A2D3FCAD-823A-476E-8B64-08133BA4013A}" type="slidenum">
               <a:rPr lang="en-US" smtClean="0"/>
-              <a:t>13</a:t>
+              <a:t>12</a:t>
             </a:fld>
             <a:endParaRPr lang="en-US"/>
           </a:p>
@@ -20242,6 +22302,209 @@
     <p:extLst>
       <p:ext uri="{BB962C8B-B14F-4D97-AF65-F5344CB8AC3E}">
         <p14:creationId xmlns:p14="http://schemas.microsoft.com/office/powerpoint/2010/main" val="2297351228"/>
+      </p:ext>
+    </p:extLst>
+  </p:cSld>
+  <p:clrMapOvr>
+    <a:masterClrMapping/>
+  </p:clrMapOvr>
+</p:sld>
+</file>
+
+<file path=ppt/slides/slide13.xml><?xml version="1.0" encoding="utf-8"?>
+<p:sld xmlns:a="http://schemas.openxmlformats.org/drawingml/2006/main" xmlns:r="http://schemas.openxmlformats.org/officeDocument/2006/relationships" xmlns:p="http://schemas.openxmlformats.org/presentationml/2006/main">
+  <p:cSld>
+    <p:spTree>
+      <p:nvGrpSpPr>
+        <p:cNvPr id="1" name="">
+          <a:extLst>
+            <a:ext uri="{FF2B5EF4-FFF2-40B4-BE49-F238E27FC236}">
+              <a16:creationId xmlns:a16="http://schemas.microsoft.com/office/drawing/2014/main" id="{1D6E7B34-7566-6C1C-3E73-31DD7B6F9C27}"/>
+            </a:ext>
+          </a:extLst>
+        </p:cNvPr>
+        <p:cNvGrpSpPr/>
+        <p:nvPr/>
+      </p:nvGrpSpPr>
+      <p:grpSpPr>
+        <a:xfrm>
+          <a:off x="0" y="0"/>
+          <a:ext cx="0" cy="0"/>
+          <a:chOff x="0" y="0"/>
+          <a:chExt cx="0" cy="0"/>
+        </a:xfrm>
+      </p:grpSpPr>
+      <p:sp>
+        <p:nvSpPr>
+          <p:cNvPr id="2" name="Title 1">
+            <a:extLst>
+              <a:ext uri="{FF2B5EF4-FFF2-40B4-BE49-F238E27FC236}">
+                <a16:creationId xmlns:a16="http://schemas.microsoft.com/office/drawing/2014/main" id="{5651FA92-F35F-8FA4-78C5-AEA23F3973E6}"/>
+              </a:ext>
+            </a:extLst>
+          </p:cNvPr>
+          <p:cNvSpPr>
+            <a:spLocks noGrp="1"/>
+          </p:cNvSpPr>
+          <p:nvPr>
+            <p:ph type="title"/>
+          </p:nvPr>
+        </p:nvSpPr>
+        <p:spPr/>
+        <p:txBody>
+          <a:bodyPr/>
+          <a:lstStyle/>
+          <a:p>
+            <a:r>
+              <a:rPr lang="en-US" dirty="0"/>
+              <a:t>Infrastructure: Hardware</a:t>
+            </a:r>
+          </a:p>
+        </p:txBody>
+      </p:sp>
+      <p:sp>
+        <p:nvSpPr>
+          <p:cNvPr id="3" name="Content Placeholder 2">
+            <a:extLst>
+              <a:ext uri="{FF2B5EF4-FFF2-40B4-BE49-F238E27FC236}">
+                <a16:creationId xmlns:a16="http://schemas.microsoft.com/office/drawing/2014/main" id="{CC7507F7-5773-D64A-AA0F-35A2797879DD}"/>
+              </a:ext>
+            </a:extLst>
+          </p:cNvPr>
+          <p:cNvSpPr>
+            <a:spLocks noGrp="1"/>
+          </p:cNvSpPr>
+          <p:nvPr>
+            <p:ph sz="quarter" idx="13"/>
+          </p:nvPr>
+        </p:nvSpPr>
+        <p:spPr/>
+        <p:txBody>
+          <a:bodyPr>
+            <a:normAutofit/>
+          </a:bodyPr>
+          <a:lstStyle/>
+          <a:p>
+            <a:r>
+              <a:rPr lang="en-US" b="1" dirty="0"/>
+              <a:t>Server Machine</a:t>
+            </a:r>
+          </a:p>
+          <a:p>
+            <a:pPr lvl="1"/>
+            <a:r>
+              <a:rPr lang="en-US" dirty="0"/>
+              <a:t>Runs the model backend used throughout testing</a:t>
+            </a:r>
+          </a:p>
+          <a:p>
+            <a:pPr lvl="1"/>
+            <a:r>
+              <a:rPr lang="en-US" dirty="0"/>
+              <a:t>Configured for persistent hosting and remote inference</a:t>
+            </a:r>
+          </a:p>
+          <a:p>
+            <a:pPr marL="0" indent="0">
+              <a:buNone/>
+            </a:pPr>
+            <a:endParaRPr lang="en-US" sz="1600" dirty="0"/>
+          </a:p>
+          <a:p>
+            <a:r>
+              <a:rPr lang="en-US" b="1" dirty="0"/>
+              <a:t>NVIDIA GeForce RTX 3090</a:t>
+            </a:r>
+          </a:p>
+          <a:p>
+            <a:pPr lvl="1"/>
+            <a:r>
+              <a:rPr lang="en-US" dirty="0"/>
+              <a:t>Excellent performance on large-parameter models (likely due to it’s 24GB VRAM)</a:t>
+            </a:r>
+          </a:p>
+          <a:p>
+            <a:pPr lvl="1"/>
+            <a:r>
+              <a:rPr lang="en-US" dirty="0"/>
+              <a:t>Strong sustained throughput for longer generations</a:t>
+            </a:r>
+          </a:p>
+          <a:p>
+            <a:pPr lvl="1"/>
+            <a:r>
+              <a:rPr lang="en-US" dirty="0"/>
+              <a:t>Slightly slower initial response time but very stable under heavy load</a:t>
+            </a:r>
+          </a:p>
+          <a:p>
+            <a:pPr marL="0" indent="0">
+              <a:buNone/>
+            </a:pPr>
+            <a:endParaRPr lang="en-US" sz="1600" dirty="0"/>
+          </a:p>
+          <a:p>
+            <a:r>
+              <a:rPr lang="en-US" b="1" dirty="0"/>
+              <a:t>NVIDIA GeForce RTX 4080</a:t>
+            </a:r>
+          </a:p>
+          <a:p>
+            <a:pPr lvl="1"/>
+            <a:r>
+              <a:rPr lang="en-US" dirty="0"/>
+              <a:t>Faster per-token generation speed on small to mid-sized models</a:t>
+            </a:r>
+          </a:p>
+          <a:p>
+            <a:pPr lvl="1"/>
+            <a:r>
+              <a:rPr lang="en-US" dirty="0"/>
+              <a:t>More efficient power usage and lower heat under similar workloads</a:t>
+            </a:r>
+          </a:p>
+          <a:p>
+            <a:pPr lvl="1"/>
+            <a:r>
+              <a:rPr lang="en-US" dirty="0"/>
+              <a:t>Limited by 16GB VRAM for the very largest models, but outperforming 3090 on moderate ones</a:t>
+            </a:r>
+          </a:p>
+        </p:txBody>
+      </p:sp>
+      <p:sp>
+        <p:nvSpPr>
+          <p:cNvPr id="4" name="Slide Number Placeholder 3">
+            <a:extLst>
+              <a:ext uri="{FF2B5EF4-FFF2-40B4-BE49-F238E27FC236}">
+                <a16:creationId xmlns:a16="http://schemas.microsoft.com/office/drawing/2014/main" id="{9ED22345-DF86-CCE8-B098-144EFCECA2EC}"/>
+              </a:ext>
+            </a:extLst>
+          </p:cNvPr>
+          <p:cNvSpPr>
+            <a:spLocks noGrp="1"/>
+          </p:cNvSpPr>
+          <p:nvPr>
+            <p:ph type="sldNum" sz="quarter" idx="16"/>
+          </p:nvPr>
+        </p:nvSpPr>
+        <p:spPr/>
+        <p:txBody>
+          <a:bodyPr/>
+          <a:lstStyle/>
+          <a:p>
+            <a:fld id="{A2D3FCAD-823A-476E-8B64-08133BA4013A}" type="slidenum">
+              <a:rPr lang="en-US" smtClean="0"/>
+              <a:t>13</a:t>
+            </a:fld>
+            <a:endParaRPr lang="en-US"/>
+          </a:p>
+        </p:txBody>
+      </p:sp>
+    </p:spTree>
+    <p:extLst>
+      <p:ext uri="{BB962C8B-B14F-4D97-AF65-F5344CB8AC3E}">
+        <p14:creationId xmlns:p14="http://schemas.microsoft.com/office/powerpoint/2010/main" val="2043502784"/>
       </p:ext>
     </p:extLst>
   </p:cSld>

</xml_diff>

<commit_message>
Updated base model values
</commit_message>
<xml_diff>
--- a/Final_Presentation.pptx
+++ b/Final_Presentation.pptx
@@ -244,7 +244,7 @@
           <a:p>
             <a:fld id="{F4628003-0FBA-A54E-A68C-FDC9D58E7C1C}" type="datetimeFigureOut">
               <a:rPr lang="en-US" smtClean="0"/>
-              <a:t>01-Dec-25</a:t>
+              <a:t>12/01/2025</a:t>
             </a:fld>
             <a:endParaRPr lang="en-US"/>
           </a:p>
@@ -421,7 +421,7 @@
           <a:p>
             <a:fld id="{EC3ABEF8-7173-4009-9FAA-9F7A030B9149}" type="datetimeFigureOut">
               <a:rPr lang="en-US" smtClean="0"/>
-              <a:t>01-Dec-25</a:t>
+              <a:t>12/01/2025</a:t>
             </a:fld>
             <a:endParaRPr lang="en-US"/>
           </a:p>
@@ -15446,7 +15446,7 @@
           <a:p>
             <a:fld id="{F56E7548-C4D4-4DB1-87F4-65ED937B3DB2}" type="datetimeFigureOut">
               <a:rPr lang="en-US" smtClean="0"/>
-              <a:t>01-Dec-25</a:t>
+              <a:t>12/01/2025</a:t>
             </a:fld>
             <a:endParaRPr lang="en-US"/>
           </a:p>
@@ -19565,9 +19565,10 @@
           <a:lstStyle/>
           <a:p>
             <a:r>
-              <a:rPr lang="en-US" dirty="0"/>
-              <a:t>Let’s Get This Breadboard: An Agentic Approach to Recipe Generation</a:t>
-            </a:r>
+              <a:rPr lang="en-US"/>
+              <a:t>Byte-Sized Cooking: Recipes à la LLM</a:t>
+            </a:r>
+            <a:endParaRPr lang="en-US" dirty="0"/>
           </a:p>
         </p:txBody>
       </p:sp>
@@ -19586,7 +19587,7 @@
           <p:nvPr>
             <p:extLst>
               <p:ext uri="{D42A27DB-BD31-4B8C-83A1-F6EECF244321}">
-                <p14:modId xmlns:p14="http://schemas.microsoft.com/office/powerpoint/2010/main" val="1703136704"/>
+                <p14:modId xmlns:p14="http://schemas.microsoft.com/office/powerpoint/2010/main" val="1176083936"/>
               </p:ext>
             </p:extLst>
           </p:nvPr>
@@ -19717,11 +19718,30 @@
                       </a:pPr>
                       <a:r>
                         <a:rPr lang="en-US" sz="1800" dirty="0">
-                          <a:hlinkClick r:id="rId3"/>
+                          <a:solidFill>
+                            <a:schemeClr val="accent2">
+                              <a:lumMod val="20000"/>
+                              <a:lumOff val="80000"/>
+                            </a:schemeClr>
+                          </a:solidFill>
+                          <a:hlinkClick r:id="rId3">
+                            <a:extLst>
+                              <a:ext uri="{A12FA001-AC4F-418D-AE19-62706E023703}">
+                                <ahyp:hlinkClr xmlns:ahyp="http://schemas.microsoft.com/office/drawing/2018/hyperlinkcolor" val="tx"/>
+                              </a:ext>
+                            </a:extLst>
+                          </a:hlinkClick>
                         </a:rPr>
                         <a:t>sellis37@jh.edu</a:t>
                       </a:r>
-                      <a:endParaRPr lang="en-US" sz="1800" dirty="0"/>
+                      <a:endParaRPr lang="en-US" sz="1800" dirty="0">
+                        <a:solidFill>
+                          <a:schemeClr val="accent2">
+                            <a:lumMod val="20000"/>
+                            <a:lumOff val="80000"/>
+                          </a:schemeClr>
+                        </a:solidFill>
+                      </a:endParaRPr>
                     </a:p>
                   </a:txBody>
                   <a:tcPr/>
@@ -19750,11 +19770,30 @@
                       </a:pPr>
                       <a:r>
                         <a:rPr lang="en-US" sz="1800" dirty="0">
-                          <a:hlinkClick r:id="rId4"/>
+                          <a:solidFill>
+                            <a:schemeClr val="accent2">
+                              <a:lumMod val="20000"/>
+                              <a:lumOff val="80000"/>
+                            </a:schemeClr>
+                          </a:solidFill>
+                          <a:hlinkClick r:id="rId4">
+                            <a:extLst>
+                              <a:ext uri="{A12FA001-AC4F-418D-AE19-62706E023703}">
+                                <ahyp:hlinkClr xmlns:ahyp="http://schemas.microsoft.com/office/drawing/2018/hyperlinkcolor" val="tx"/>
+                              </a:ext>
+                            </a:extLst>
+                          </a:hlinkClick>
                         </a:rPr>
                         <a:t>shuan153@jh.edu</a:t>
                       </a:r>
-                      <a:endParaRPr lang="en-US" sz="1800" dirty="0"/>
+                      <a:endParaRPr lang="en-US" sz="1800" dirty="0">
+                        <a:solidFill>
+                          <a:schemeClr val="accent2">
+                            <a:lumMod val="20000"/>
+                            <a:lumOff val="80000"/>
+                          </a:schemeClr>
+                        </a:solidFill>
+                      </a:endParaRPr>
                     </a:p>
                   </a:txBody>
                   <a:tcPr/>

</xml_diff>